<commit_message>
Deck 01e (student copy): fashion brand case added
Co-Authored-By: Claude Opus 5.5 <noreply@anthropic.com>
Claude-Session: https://claude.ai/code/session_01TbrdxHn7W6FVXXnpqzNytd
</commit_message>
<xml_diff>
--- a/slides/01e_regression-assumptions-dummies-nonlinear_WT26-27.pptx
+++ b/slides/01e_regression-assumptions-dummies-nonlinear_WT26-27.pptx
@@ -52,7 +52,9 @@
     <p:sldId id="296" r:id="rId53"/>
     <p:sldId id="297" r:id="rId54"/>
     <p:sldId id="298" r:id="rId55"/>
-    <p:sldId id="299" r:id="rId56"/>
+    <p:sldId id="300" r:id="rId57"/>
+    <p:sldId id="301" r:id="rId58"/>
+    <p:sldId id="302" r:id="rId59"/>
   </p:sldIdLst>
   <p:sldSz cx="9144000" cy="5715000" type="screen16x10"/>
   <p:notesSz cx="6858000" cy="9144000"/>
@@ -3224,7 +3226,7 @@
           <a:lstStyle/>
           <a:p>
             <a:r>
-              <a:t>If students remember one thing: look at the residuals before you trust a regression; for sales data the log-log model usually fixes the form, the funnel and the tails at once.</a:t>
+              <a:t>Real data, anonymised: one fashion brand on a large online fashion platform, sales by article type and country for the Spring/Summer 2025 and 2026 collections, 403 rows. Volumes and money are rescaled, shares and conversion are original. Each row adds up a whole season, so the data are cross-sectional: good for log-log models and country dummies, not for a marketing mix model (no weeks, no media spend). DE, CH and AT make 71 % of NMV in SS26. Switzerland is new in SS26 and converts best at once; Italy and Sweden convert worst. The brand manager's questions: where do page views turn into sales, and should we invest in Switzerland?</a:t>
             </a:r>
           </a:p>
         </p:txBody>
@@ -3294,7 +3296,7 @@
           <a:lstStyle/>
           <a:p>
             <a:r>
-              <a:t>Core readings first. Wooldridge covers every test in more depth; ISLP chapter 3 has a Python lab on residual plots and non-linear terms.</a:t>
+              <a:t>Same routine: pairs with the packages (20 minutes), plenary, then Posit Assistant. The file has the data table, five tasks and a Posit Assistant section with example prompts. Watch for: np.log of zero sales (filter them), the alphabetical reference country (AT) instead of Treatment('DE'), unweighted means of return rates, and the price coefficient read as a price elasticity.</a:t>
             </a:r>
           </a:p>
         </p:txBody>
@@ -3319,7 +3321,147 @@
 </p:notes>
 </file>
 
-<file path=ppt/notesSlides/notesSlide44.xml><?xml version="1.0" encoding="utf-8"?>
+<file path=ppt/notesSlides/notesSlide45.xml><?xml version="1.0" encoding="utf-8"?>
+<p:notes xmlns:a="http://schemas.openxmlformats.org/drawingml/2006/main" xmlns:p="http://schemas.openxmlformats.org/presentationml/2006/main" xmlns:r="http://schemas.openxmlformats.org/officeDocument/2006/relationships">
+  <p:cSld>
+    <p:spTree>
+      <p:nvGrpSpPr>
+        <p:cNvPr id="1" name=""/>
+        <p:cNvGrpSpPr/>
+        <p:nvPr/>
+      </p:nvGrpSpPr>
+      <p:grpSpPr>
+        <a:xfrm>
+          <a:off x="0" y="0"/>
+          <a:ext cx="0" cy="0"/>
+          <a:chOff x="0" y="0"/>
+          <a:chExt cx="0" cy="0"/>
+        </a:xfrm>
+      </p:grpSpPr>
+      <p:sp>
+        <p:nvSpPr>
+          <p:cNvPr id="2" name="Slide Image Placeholder 1"/>
+          <p:cNvSpPr>
+            <a:spLocks noGrp="1"/>
+          </p:cNvSpPr>
+          <p:nvPr>
+            <p:ph type="sldImg" idx="2"/>
+          </p:nvPr>
+        </p:nvSpPr>
+        <p:spPr/>
+      </p:sp>
+      <p:sp>
+        <p:nvSpPr>
+          <p:cNvPr id="3" name="Notes Placeholder 2"/>
+          <p:cNvSpPr>
+            <a:spLocks noGrp="1"/>
+          </p:cNvSpPr>
+          <p:nvPr>
+            <p:ph type="body" idx="3" sz="quarter"/>
+          </p:nvPr>
+        </p:nvSpPr>
+        <p:spPr/>
+        <p:txBody>
+          <a:bodyPr/>
+          <a:lstStyle/>
+          <a:p>
+            <a:r>
+              <a:t>If students remember one thing: look at the residuals before you trust a regression; for sales data the log-log model usually fixes the form, the funnel and the tails at once.</a:t>
+            </a:r>
+          </a:p>
+        </p:txBody>
+      </p:sp>
+      <p:sp>
+        <p:nvSpPr>
+          <p:cNvPr id="4" name="Slide Number Placeholder 3"/>
+          <p:cNvSpPr>
+            <a:spLocks noGrp="1"/>
+          </p:cNvSpPr>
+          <p:nvPr>
+            <p:ph type="sldNum" idx="5" sz="quarter"/>
+          </p:nvPr>
+        </p:nvSpPr>
+        <p:spPr/>
+      </p:sp>
+    </p:spTree>
+  </p:cSld>
+  <p:clrMapOvr>
+    <a:masterClrMapping/>
+  </p:clrMapOvr>
+</p:notes>
+</file>
+
+<file path=ppt/notesSlides/notesSlide46.xml><?xml version="1.0" encoding="utf-8"?>
+<p:notes xmlns:a="http://schemas.openxmlformats.org/drawingml/2006/main" xmlns:p="http://schemas.openxmlformats.org/presentationml/2006/main" xmlns:r="http://schemas.openxmlformats.org/officeDocument/2006/relationships">
+  <p:cSld>
+    <p:spTree>
+      <p:nvGrpSpPr>
+        <p:cNvPr id="1" name=""/>
+        <p:cNvGrpSpPr/>
+        <p:nvPr/>
+      </p:nvGrpSpPr>
+      <p:grpSpPr>
+        <a:xfrm>
+          <a:off x="0" y="0"/>
+          <a:ext cx="0" cy="0"/>
+          <a:chOff x="0" y="0"/>
+          <a:chExt cx="0" cy="0"/>
+        </a:xfrm>
+      </p:grpSpPr>
+      <p:sp>
+        <p:nvSpPr>
+          <p:cNvPr id="2" name="Slide Image Placeholder 1"/>
+          <p:cNvSpPr>
+            <a:spLocks noGrp="1"/>
+          </p:cNvSpPr>
+          <p:nvPr>
+            <p:ph type="sldImg" idx="2"/>
+          </p:nvPr>
+        </p:nvSpPr>
+        <p:spPr/>
+      </p:sp>
+      <p:sp>
+        <p:nvSpPr>
+          <p:cNvPr id="3" name="Notes Placeholder 2"/>
+          <p:cNvSpPr>
+            <a:spLocks noGrp="1"/>
+          </p:cNvSpPr>
+          <p:nvPr>
+            <p:ph type="body" idx="3" sz="quarter"/>
+          </p:nvPr>
+        </p:nvSpPr>
+        <p:spPr/>
+        <p:txBody>
+          <a:bodyPr/>
+          <a:lstStyle/>
+          <a:p>
+            <a:r>
+              <a:t>Core readings first. Wooldridge covers every test in more depth; ISLP chapter 3 has a Python lab on residual plots and non-linear terms.</a:t>
+            </a:r>
+          </a:p>
+        </p:txBody>
+      </p:sp>
+      <p:sp>
+        <p:nvSpPr>
+          <p:cNvPr id="4" name="Slide Number Placeholder 3"/>
+          <p:cNvSpPr>
+            <a:spLocks noGrp="1"/>
+          </p:cNvSpPr>
+          <p:nvPr>
+            <p:ph type="sldNum" idx="5" sz="quarter"/>
+          </p:nvPr>
+        </p:nvSpPr>
+        <p:spPr/>
+      </p:sp>
+    </p:spTree>
+  </p:cSld>
+  <p:clrMapOvr>
+    <a:masterClrMapping/>
+  </p:clrMapOvr>
+</p:notes>
+</file>
+
+<file path=ppt/notesSlides/notesSlide47.xml><?xml version="1.0" encoding="utf-8"?>
 <p:notes xmlns:a="http://schemas.openxmlformats.org/drawingml/2006/main" xmlns:p="http://schemas.openxmlformats.org/presentationml/2006/main" xmlns:r="http://schemas.openxmlformats.org/officeDocument/2006/relationships">
   <p:cSld>
     <p:spTree>
@@ -24400,7 +24542,7 @@
                   <a:schemeClr val="tx1"/>
                 </a:solidFill>
               </a:rPr>
-              <a:t>Coding exercise in pairs, then the answers</a:t>
+              <a:t>Two coding cases: chocolate and fashion</a:t>
             </a:r>
           </a:p>
           <a:p>
@@ -43719,7 +43861,7 @@
           <a:p>
             <a:r>
               <a:rPr sz="1600" lang="en-GB"/>
-              <a:t>Key takeaways</a:t>
+              <a:t>Second case: one fashion brand, twelve countries</a:t>
             </a:r>
           </a:p>
         </p:txBody>
@@ -43773,16 +43915,40 @@
           </a:p>
         </p:txBody>
       </p:sp>
-      <p:sp>
-        <p:nvSpPr>
-          <p:cNvPr id="10" name="Takeaways row 1"/>
+      <p:pic>
+        <p:nvPicPr>
+          <p:cNvPr id="10" name="Chart fa_conversion.png" descr="Horizontal bar chart of sold articles per 100 product page views in SS26 by country: CH 6.3 (highlighted), AT 5.7, DE 5.5, DK 4.3, BE 4.1, NL 3.9, PL 2.9, FI 2.8, CZ 2.7, FR 2.3, SE 1.7, IT 1.7"/>
+          <p:cNvPicPr>
+            <a:picLocks noChangeAspect="1"/>
+          </p:cNvPicPr>
+          <p:nvPr/>
+        </p:nvPicPr>
+        <p:blipFill>
+          <a:blip r:embed="rId3"/>
+          <a:stretch>
+            <a:fillRect/>
+          </a:stretch>
+        </p:blipFill>
+        <p:spPr>
+          <a:xfrm>
+            <a:off x="457200" y="1234440"/>
+            <a:ext cx="3977640" cy="2962656"/>
+          </a:xfrm>
+          <a:prstGeom prst="rect">
+            <a:avLst/>
+          </a:prstGeom>
+        </p:spPr>
+      </p:pic>
+      <p:sp>
+        <p:nvSpPr>
+          <p:cNvPr id="11" name="Fashion data row 1"/>
           <p:cNvSpPr/>
           <p:nvPr/>
         </p:nvSpPr>
         <p:spPr>
           <a:xfrm>
-            <a:off x="457200" y="1234440"/>
-            <a:ext cx="8229600" cy="585216"/>
+            <a:off x="4572000" y="1234440"/>
+            <a:ext cx="4114800" cy="548640"/>
           </a:xfrm>
           <a:prstGeom prst="rect">
             <a:avLst/>
@@ -43817,16 +43983,494 @@
       </p:sp>
       <p:sp>
         <p:nvSpPr>
-          <p:cNvPr id="11" name="Takeaways number 1"/>
+          <p:cNvPr id="12" name="Fashion data bar 1"/>
           <p:cNvSpPr/>
           <p:nvPr/>
         </p:nvSpPr>
         <p:spPr>
           <a:xfrm>
-            <a:off x="594360" y="1371600"/>
-            <a:ext cx="310896" cy="310896"/>
-          </a:xfrm>
-          <a:prstGeom prst="ellipse">
+            <a:off x="4572000" y="1234440"/>
+            <a:ext cx="64008" cy="548640"/>
+          </a:xfrm>
+          <a:prstGeom prst="rect">
+            <a:avLst/>
+          </a:prstGeom>
+          <a:solidFill>
+            <a:schemeClr val="accent1"/>
+          </a:solidFill>
+          <a:ln>
+            <a:noFill/>
+          </a:ln>
+          <a:effectLst/>
+        </p:spPr>
+        <p:style>
+          <a:lnRef idx="1">
+            <a:schemeClr val="accent1"/>
+          </a:lnRef>
+          <a:fillRef idx="3">
+            <a:schemeClr val="accent1"/>
+          </a:fillRef>
+          <a:effectRef idx="2">
+            <a:schemeClr val="accent1"/>
+          </a:effectRef>
+          <a:fontRef idx="minor">
+            <a:schemeClr val="lt1"/>
+          </a:fontRef>
+        </p:style>
+        <p:txBody>
+          <a:bodyPr rtlCol="0" anchor="ctr"/>
+          <a:lstStyle/>
+          <a:p/>
+        </p:txBody>
+      </p:sp>
+      <p:sp>
+        <p:nvSpPr>
+          <p:cNvPr id="13" name="Fashion data text 1"/>
+          <p:cNvSpPr txBox="1"/>
+          <p:nvPr/>
+        </p:nvSpPr>
+        <p:spPr>
+          <a:xfrm>
+            <a:off x="4773168" y="1234440"/>
+            <a:ext cx="3822192" cy="548640"/>
+          </a:xfrm>
+          <a:prstGeom prst="rect">
+            <a:avLst/>
+          </a:prstGeom>
+          <a:noFill/>
+        </p:spPr>
+        <p:txBody>
+          <a:bodyPr wrap="square" lIns="0" rIns="0" tIns="0" bIns="0" anchor="ctr">
+            <a:noAutofit/>
+          </a:bodyPr>
+          <a:lstStyle/>
+          <a:p>
+            <a:pPr algn="l">
+              <a:spcAft>
+                <a:spcPts val="400"/>
+              </a:spcAft>
+            </a:pPr>
+            <a:r>
+              <a:rPr sz="1200" b="1" lang="en-GB">
+                <a:solidFill>
+                  <a:schemeClr val="tx2"/>
+                </a:solidFill>
+              </a:rPr>
+              <a:t>Data: </a:t>
+            </a:r>
+            <a:r>
+              <a:rPr sz="1200" b="0" lang="en-GB">
+                <a:solidFill>
+                  <a:schemeClr val="tx1"/>
+                </a:solidFill>
+              </a:rPr>
+              <a:t>403 rows, season × country × article type</a:t>
+            </a:r>
+          </a:p>
+        </p:txBody>
+      </p:sp>
+      <p:sp>
+        <p:nvSpPr>
+          <p:cNvPr id="14" name="Fashion data row 2"/>
+          <p:cNvSpPr/>
+          <p:nvPr/>
+        </p:nvSpPr>
+        <p:spPr>
+          <a:xfrm>
+            <a:off x="4572000" y="1856232"/>
+            <a:ext cx="4114800" cy="548640"/>
+          </a:xfrm>
+          <a:prstGeom prst="rect">
+            <a:avLst/>
+          </a:prstGeom>
+          <a:solidFill>
+            <a:schemeClr val="bg2"/>
+          </a:solidFill>
+          <a:ln>
+            <a:noFill/>
+          </a:ln>
+          <a:effectLst/>
+        </p:spPr>
+        <p:style>
+          <a:lnRef idx="1">
+            <a:schemeClr val="accent1"/>
+          </a:lnRef>
+          <a:fillRef idx="3">
+            <a:schemeClr val="accent1"/>
+          </a:fillRef>
+          <a:effectRef idx="2">
+            <a:schemeClr val="accent1"/>
+          </a:effectRef>
+          <a:fontRef idx="minor">
+            <a:schemeClr val="lt1"/>
+          </a:fontRef>
+        </p:style>
+        <p:txBody>
+          <a:bodyPr rtlCol="0" anchor="ctr"/>
+          <a:lstStyle/>
+          <a:p/>
+        </p:txBody>
+      </p:sp>
+      <p:sp>
+        <p:nvSpPr>
+          <p:cNvPr id="15" name="Fashion data bar 2"/>
+          <p:cNvSpPr/>
+          <p:nvPr/>
+        </p:nvSpPr>
+        <p:spPr>
+          <a:xfrm>
+            <a:off x="4572000" y="1856232"/>
+            <a:ext cx="64008" cy="548640"/>
+          </a:xfrm>
+          <a:prstGeom prst="rect">
+            <a:avLst/>
+          </a:prstGeom>
+          <a:solidFill>
+            <a:schemeClr val="accent1"/>
+          </a:solidFill>
+          <a:ln>
+            <a:noFill/>
+          </a:ln>
+          <a:effectLst/>
+        </p:spPr>
+        <p:style>
+          <a:lnRef idx="1">
+            <a:schemeClr val="accent1"/>
+          </a:lnRef>
+          <a:fillRef idx="3">
+            <a:schemeClr val="accent1"/>
+          </a:fillRef>
+          <a:effectRef idx="2">
+            <a:schemeClr val="accent1"/>
+          </a:effectRef>
+          <a:fontRef idx="minor">
+            <a:schemeClr val="lt1"/>
+          </a:fontRef>
+        </p:style>
+        <p:txBody>
+          <a:bodyPr rtlCol="0" anchor="ctr"/>
+          <a:lstStyle/>
+          <a:p/>
+        </p:txBody>
+      </p:sp>
+      <p:sp>
+        <p:nvSpPr>
+          <p:cNvPr id="16" name="Fashion data text 2"/>
+          <p:cNvSpPr txBox="1"/>
+          <p:nvPr/>
+        </p:nvSpPr>
+        <p:spPr>
+          <a:xfrm>
+            <a:off x="4773168" y="1856232"/>
+            <a:ext cx="3822192" cy="548640"/>
+          </a:xfrm>
+          <a:prstGeom prst="rect">
+            <a:avLst/>
+          </a:prstGeom>
+          <a:noFill/>
+        </p:spPr>
+        <p:txBody>
+          <a:bodyPr wrap="square" lIns="0" rIns="0" tIns="0" bIns="0" anchor="ctr">
+            <a:noAutofit/>
+          </a:bodyPr>
+          <a:lstStyle/>
+          <a:p>
+            <a:pPr algn="l">
+              <a:spcAft>
+                <a:spcPts val="400"/>
+              </a:spcAft>
+            </a:pPr>
+            <a:r>
+              <a:rPr sz="1200" b="1" lang="en-GB">
+                <a:solidFill>
+                  <a:schemeClr val="tx2"/>
+                </a:solidFill>
+              </a:rPr>
+              <a:t>Funnel: </a:t>
+            </a:r>
+            <a:r>
+              <a:rPr sz="1200" b="0" lang="en-GB">
+                <a:solidFill>
+                  <a:schemeClr val="tx1"/>
+                </a:solidFill>
+              </a:rPr>
+              <a:t>page views → add to basket → sold → returns</a:t>
+            </a:r>
+          </a:p>
+        </p:txBody>
+      </p:sp>
+      <p:sp>
+        <p:nvSpPr>
+          <p:cNvPr id="17" name="Fashion data row 3"/>
+          <p:cNvSpPr/>
+          <p:nvPr/>
+        </p:nvSpPr>
+        <p:spPr>
+          <a:xfrm>
+            <a:off x="4572000" y="2478024"/>
+            <a:ext cx="4114800" cy="548640"/>
+          </a:xfrm>
+          <a:prstGeom prst="rect">
+            <a:avLst/>
+          </a:prstGeom>
+          <a:solidFill>
+            <a:schemeClr val="bg2"/>
+          </a:solidFill>
+          <a:ln>
+            <a:noFill/>
+          </a:ln>
+          <a:effectLst/>
+        </p:spPr>
+        <p:style>
+          <a:lnRef idx="1">
+            <a:schemeClr val="accent1"/>
+          </a:lnRef>
+          <a:fillRef idx="3">
+            <a:schemeClr val="accent1"/>
+          </a:fillRef>
+          <a:effectRef idx="2">
+            <a:schemeClr val="accent1"/>
+          </a:effectRef>
+          <a:fontRef idx="minor">
+            <a:schemeClr val="lt1"/>
+          </a:fontRef>
+        </p:style>
+        <p:txBody>
+          <a:bodyPr rtlCol="0" anchor="ctr"/>
+          <a:lstStyle/>
+          <a:p/>
+        </p:txBody>
+      </p:sp>
+      <p:sp>
+        <p:nvSpPr>
+          <p:cNvPr id="18" name="Fashion data bar 3"/>
+          <p:cNvSpPr/>
+          <p:nvPr/>
+        </p:nvSpPr>
+        <p:spPr>
+          <a:xfrm>
+            <a:off x="4572000" y="2478024"/>
+            <a:ext cx="64008" cy="548640"/>
+          </a:xfrm>
+          <a:prstGeom prst="rect">
+            <a:avLst/>
+          </a:prstGeom>
+          <a:solidFill>
+            <a:schemeClr val="accent1"/>
+          </a:solidFill>
+          <a:ln>
+            <a:noFill/>
+          </a:ln>
+          <a:effectLst/>
+        </p:spPr>
+        <p:style>
+          <a:lnRef idx="1">
+            <a:schemeClr val="accent1"/>
+          </a:lnRef>
+          <a:fillRef idx="3">
+            <a:schemeClr val="accent1"/>
+          </a:fillRef>
+          <a:effectRef idx="2">
+            <a:schemeClr val="accent1"/>
+          </a:effectRef>
+          <a:fontRef idx="minor">
+            <a:schemeClr val="lt1"/>
+          </a:fontRef>
+        </p:style>
+        <p:txBody>
+          <a:bodyPr rtlCol="0" anchor="ctr"/>
+          <a:lstStyle/>
+          <a:p/>
+        </p:txBody>
+      </p:sp>
+      <p:sp>
+        <p:nvSpPr>
+          <p:cNvPr id="19" name="Fashion data text 3"/>
+          <p:cNvSpPr txBox="1"/>
+          <p:nvPr/>
+        </p:nvSpPr>
+        <p:spPr>
+          <a:xfrm>
+            <a:off x="4773168" y="2478024"/>
+            <a:ext cx="3822192" cy="548640"/>
+          </a:xfrm>
+          <a:prstGeom prst="rect">
+            <a:avLst/>
+          </a:prstGeom>
+          <a:noFill/>
+        </p:spPr>
+        <p:txBody>
+          <a:bodyPr wrap="square" lIns="0" rIns="0" tIns="0" bIns="0" anchor="ctr">
+            <a:noAutofit/>
+          </a:bodyPr>
+          <a:lstStyle/>
+          <a:p>
+            <a:pPr algn="l">
+              <a:spcAft>
+                <a:spcPts val="400"/>
+              </a:spcAft>
+            </a:pPr>
+            <a:r>
+              <a:rPr sz="1200" b="1" lang="en-GB">
+                <a:solidFill>
+                  <a:schemeClr val="tx2"/>
+                </a:solidFill>
+              </a:rPr>
+              <a:t>Markets: </a:t>
+            </a:r>
+            <a:r>
+              <a:rPr sz="1200" b="0" lang="en-GB">
+                <a:solidFill>
+                  <a:schemeClr val="tx1"/>
+                </a:solidFill>
+              </a:rPr>
+              <a:t>DE, CH, AT = 71 % of NMV in SS26</a:t>
+            </a:r>
+          </a:p>
+        </p:txBody>
+      </p:sp>
+      <p:sp>
+        <p:nvSpPr>
+          <p:cNvPr id="20" name="Fashion data row 4"/>
+          <p:cNvSpPr/>
+          <p:nvPr/>
+        </p:nvSpPr>
+        <p:spPr>
+          <a:xfrm>
+            <a:off x="4572000" y="3099816"/>
+            <a:ext cx="4114800" cy="548640"/>
+          </a:xfrm>
+          <a:prstGeom prst="rect">
+            <a:avLst/>
+          </a:prstGeom>
+          <a:solidFill>
+            <a:schemeClr val="bg2"/>
+          </a:solidFill>
+          <a:ln>
+            <a:noFill/>
+          </a:ln>
+          <a:effectLst/>
+        </p:spPr>
+        <p:style>
+          <a:lnRef idx="1">
+            <a:schemeClr val="accent1"/>
+          </a:lnRef>
+          <a:fillRef idx="3">
+            <a:schemeClr val="accent1"/>
+          </a:fillRef>
+          <a:effectRef idx="2">
+            <a:schemeClr val="accent1"/>
+          </a:effectRef>
+          <a:fontRef idx="minor">
+            <a:schemeClr val="lt1"/>
+          </a:fontRef>
+        </p:style>
+        <p:txBody>
+          <a:bodyPr rtlCol="0" anchor="ctr"/>
+          <a:lstStyle/>
+          <a:p/>
+        </p:txBody>
+      </p:sp>
+      <p:sp>
+        <p:nvSpPr>
+          <p:cNvPr id="21" name="Fashion data bar 4"/>
+          <p:cNvSpPr/>
+          <p:nvPr/>
+        </p:nvSpPr>
+        <p:spPr>
+          <a:xfrm>
+            <a:off x="4572000" y="3099816"/>
+            <a:ext cx="64008" cy="548640"/>
+          </a:xfrm>
+          <a:prstGeom prst="rect">
+            <a:avLst/>
+          </a:prstGeom>
+          <a:solidFill>
+            <a:schemeClr val="accent1"/>
+          </a:solidFill>
+          <a:ln>
+            <a:noFill/>
+          </a:ln>
+          <a:effectLst/>
+        </p:spPr>
+        <p:style>
+          <a:lnRef idx="1">
+            <a:schemeClr val="accent1"/>
+          </a:lnRef>
+          <a:fillRef idx="3">
+            <a:schemeClr val="accent1"/>
+          </a:fillRef>
+          <a:effectRef idx="2">
+            <a:schemeClr val="accent1"/>
+          </a:effectRef>
+          <a:fontRef idx="minor">
+            <a:schemeClr val="lt1"/>
+          </a:fontRef>
+        </p:style>
+        <p:txBody>
+          <a:bodyPr rtlCol="0" anchor="ctr"/>
+          <a:lstStyle/>
+          <a:p/>
+        </p:txBody>
+      </p:sp>
+      <p:sp>
+        <p:nvSpPr>
+          <p:cNvPr id="22" name="Fashion data text 4"/>
+          <p:cNvSpPr txBox="1"/>
+          <p:nvPr/>
+        </p:nvSpPr>
+        <p:spPr>
+          <a:xfrm>
+            <a:off x="4773168" y="3099816"/>
+            <a:ext cx="3822192" cy="548640"/>
+          </a:xfrm>
+          <a:prstGeom prst="rect">
+            <a:avLst/>
+          </a:prstGeom>
+          <a:noFill/>
+        </p:spPr>
+        <p:txBody>
+          <a:bodyPr wrap="square" lIns="0" rIns="0" tIns="0" bIns="0" anchor="ctr">
+            <a:noAutofit/>
+          </a:bodyPr>
+          <a:lstStyle/>
+          <a:p>
+            <a:pPr algn="l">
+              <a:spcAft>
+                <a:spcPts val="400"/>
+              </a:spcAft>
+            </a:pPr>
+            <a:r>
+              <a:rPr sz="1200" b="1" lang="en-GB">
+                <a:solidFill>
+                  <a:schemeClr val="tx2"/>
+                </a:solidFill>
+              </a:rPr>
+              <a:t>New in SS26: </a:t>
+            </a:r>
+            <a:r>
+              <a:rPr sz="1200" b="0" lang="en-GB">
+                <a:solidFill>
+                  <a:schemeClr val="tx1"/>
+                </a:solidFill>
+              </a:rPr>
+              <a:t>Switzerland converts best at once</a:t>
+            </a:r>
+          </a:p>
+        </p:txBody>
+      </p:sp>
+      <p:sp>
+        <p:nvSpPr>
+          <p:cNvPr id="23" name="Fashion question box"/>
+          <p:cNvSpPr/>
+          <p:nvPr/>
+        </p:nvSpPr>
+        <p:spPr>
+          <a:xfrm>
+            <a:off x="457200" y="4251960"/>
+            <a:ext cx="8229600" cy="685800"/>
+          </a:xfrm>
+          <a:prstGeom prst="rect">
             <a:avLst/>
           </a:prstGeom>
           <a:solidFill>
@@ -43852,31 +44496,45 @@
           </a:fontRef>
         </p:style>
         <p:txBody>
-          <a:bodyPr rtlCol="0" anchor="ctr" lIns="0" rIns="0" tIns="0" bIns="0"/>
-          <a:lstStyle/>
-          <a:p>
-            <a:pPr algn="ctr"/>
-            <a:r>
-              <a:rPr sz="1200" b="1" lang="en-GB">
-                <a:solidFill>
-                  <a:schemeClr val="bg1"/>
-                </a:solidFill>
-              </a:rPr>
-              <a:t>1</a:t>
-            </a:r>
-          </a:p>
-        </p:txBody>
-      </p:sp>
-      <p:sp>
-        <p:nvSpPr>
-          <p:cNvPr id="12" name="Takeaways text 1"/>
+          <a:bodyPr rtlCol="0" anchor="ctr"/>
+          <a:lstStyle/>
+          <a:p/>
+        </p:txBody>
+      </p:sp>
+      <p:pic>
+        <p:nvPicPr>
+          <p:cNvPr id="24" name="Icon Fashion question" descr=""/>
+          <p:cNvPicPr>
+            <a:picLocks noChangeAspect="1"/>
+          </p:cNvPicPr>
+          <p:nvPr/>
+        </p:nvPicPr>
+        <p:blipFill>
+          <a:blip r:embed="rId4"/>
+          <a:stretch>
+            <a:fillRect/>
+          </a:stretch>
+        </p:blipFill>
+        <p:spPr>
+          <a:xfrm>
+            <a:off x="658368" y="4411980"/>
+            <a:ext cx="365760" cy="365760"/>
+          </a:xfrm>
+          <a:prstGeom prst="rect">
+            <a:avLst/>
+          </a:prstGeom>
+        </p:spPr>
+      </p:pic>
+      <p:sp>
+        <p:nvSpPr>
+          <p:cNvPr id="25" name="Fashion question text"/>
           <p:cNvSpPr txBox="1"/>
           <p:nvPr/>
         </p:nvSpPr>
         <p:spPr>
           <a:xfrm>
-            <a:off x="1051560" y="1234440"/>
-            <a:ext cx="7498080" cy="585216"/>
+            <a:off x="1207008" y="4251960"/>
+            <a:ext cx="7315200" cy="685800"/>
           </a:xfrm>
           <a:prstGeom prst="rect">
             <a:avLst/>
@@ -43895,692 +44553,20 @@
               </a:spcAft>
             </a:pPr>
             <a:r>
-              <a:rPr sz="1200" b="1" lang="en-GB">
-                <a:solidFill>
-                  <a:schemeClr val="tx2"/>
-                </a:solidFill>
-              </a:rPr>
-              <a:t>Look, then test, then fix: </a:t>
-            </a:r>
-            <a:r>
-              <a:rPr sz="1200" b="0" lang="en-GB">
-                <a:solidFill>
-                  <a:schemeClr val="tx1"/>
-                </a:solidFill>
-              </a:rPr>
-              <a:t>residual and Q-Q plots; RESET, Breusch-Pagan, Jarque-Bera, VIF, Cook's distance</a:t>
-            </a:r>
-          </a:p>
-        </p:txBody>
-      </p:sp>
-      <p:sp>
-        <p:nvSpPr>
-          <p:cNvPr id="13" name="Takeaways row 2"/>
-          <p:cNvSpPr/>
-          <p:nvPr/>
-        </p:nvSpPr>
-        <p:spPr>
-          <a:xfrm>
-            <a:off x="457200" y="1901952"/>
-            <a:ext cx="8229600" cy="585216"/>
-          </a:xfrm>
-          <a:prstGeom prst="rect">
-            <a:avLst/>
-          </a:prstGeom>
-          <a:solidFill>
-            <a:schemeClr val="bg2"/>
-          </a:solidFill>
-          <a:ln>
-            <a:noFill/>
-          </a:ln>
-          <a:effectLst/>
-        </p:spPr>
-        <p:style>
-          <a:lnRef idx="1">
-            <a:schemeClr val="accent1"/>
-          </a:lnRef>
-          <a:fillRef idx="3">
-            <a:schemeClr val="accent1"/>
-          </a:fillRef>
-          <a:effectRef idx="2">
-            <a:schemeClr val="accent1"/>
-          </a:effectRef>
-          <a:fontRef idx="minor">
-            <a:schemeClr val="lt1"/>
-          </a:fontRef>
-        </p:style>
-        <p:txBody>
-          <a:bodyPr rtlCol="0" anchor="ctr"/>
-          <a:lstStyle/>
-          <a:p/>
-        </p:txBody>
-      </p:sp>
-      <p:sp>
-        <p:nvSpPr>
-          <p:cNvPr id="14" name="Takeaways number 2"/>
-          <p:cNvSpPr/>
-          <p:nvPr/>
-        </p:nvSpPr>
-        <p:spPr>
-          <a:xfrm>
-            <a:off x="594360" y="2039112"/>
-            <a:ext cx="310896" cy="310896"/>
-          </a:xfrm>
-          <a:prstGeom prst="ellipse">
-            <a:avLst/>
-          </a:prstGeom>
-          <a:solidFill>
-            <a:schemeClr val="tx2"/>
-          </a:solidFill>
-          <a:ln>
-            <a:noFill/>
-          </a:ln>
-          <a:effectLst/>
-        </p:spPr>
-        <p:style>
-          <a:lnRef idx="1">
-            <a:schemeClr val="accent1"/>
-          </a:lnRef>
-          <a:fillRef idx="3">
-            <a:schemeClr val="accent1"/>
-          </a:fillRef>
-          <a:effectRef idx="2">
-            <a:schemeClr val="accent1"/>
-          </a:effectRef>
-          <a:fontRef idx="minor">
-            <a:schemeClr val="lt1"/>
-          </a:fontRef>
-        </p:style>
-        <p:txBody>
-          <a:bodyPr rtlCol="0" anchor="ctr" lIns="0" rIns="0" tIns="0" bIns="0"/>
-          <a:lstStyle/>
-          <a:p>
-            <a:pPr algn="ctr"/>
-            <a:r>
-              <a:rPr sz="1200" b="1" lang="en-GB">
+              <a:rPr sz="1250" b="1" lang="en-GB">
                 <a:solidFill>
                   <a:schemeClr val="bg1"/>
                 </a:solidFill>
               </a:rPr>
-              <a:t>2</a:t>
-            </a:r>
-          </a:p>
-        </p:txBody>
-      </p:sp>
-      <p:sp>
-        <p:nvSpPr>
-          <p:cNvPr id="15" name="Takeaways text 2"/>
-          <p:cNvSpPr txBox="1"/>
-          <p:nvPr/>
-        </p:nvSpPr>
-        <p:spPr>
-          <a:xfrm>
-            <a:off x="1051560" y="1901952"/>
-            <a:ext cx="7498080" cy="585216"/>
-          </a:xfrm>
-          <a:prstGeom prst="rect">
-            <a:avLst/>
-          </a:prstGeom>
-          <a:noFill/>
-        </p:spPr>
-        <p:txBody>
-          <a:bodyPr wrap="square" lIns="0" rIns="0" tIns="0" bIns="0" anchor="ctr">
-            <a:noAutofit/>
-          </a:bodyPr>
-          <a:lstStyle/>
-          <a:p>
-            <a:pPr algn="l">
-              <a:spcAft>
-                <a:spcPts val="400"/>
-              </a:spcAft>
-            </a:pPr>
-            <a:r>
-              <a:rPr sz="1200" b="1" lang="en-GB">
-                <a:solidFill>
-                  <a:schemeClr val="tx2"/>
-                </a:solidFill>
-              </a:rPr>
-              <a:t>In assumption tests </a:t>
-            </a:r>
-            <a:r>
-              <a:rPr sz="1200" b="0" lang="en-GB">
-                <a:solidFill>
-                  <a:schemeClr val="tx1"/>
-                </a:solidFill>
-              </a:rPr>
-              <a:t>a small p is bad news</a:t>
-            </a:r>
-          </a:p>
-        </p:txBody>
-      </p:sp>
-      <p:sp>
-        <p:nvSpPr>
-          <p:cNvPr id="16" name="Takeaways row 3"/>
-          <p:cNvSpPr/>
-          <p:nvPr/>
-        </p:nvSpPr>
-        <p:spPr>
-          <a:xfrm>
-            <a:off x="457200" y="2569464"/>
-            <a:ext cx="8229600" cy="585216"/>
-          </a:xfrm>
-          <a:prstGeom prst="rect">
-            <a:avLst/>
-          </a:prstGeom>
-          <a:solidFill>
-            <a:schemeClr val="bg2"/>
-          </a:solidFill>
-          <a:ln>
-            <a:noFill/>
-          </a:ln>
-          <a:effectLst/>
-        </p:spPr>
-        <p:style>
-          <a:lnRef idx="1">
-            <a:schemeClr val="accent1"/>
-          </a:lnRef>
-          <a:fillRef idx="3">
-            <a:schemeClr val="accent1"/>
-          </a:fillRef>
-          <a:effectRef idx="2">
-            <a:schemeClr val="accent1"/>
-          </a:effectRef>
-          <a:fontRef idx="minor">
-            <a:schemeClr val="lt1"/>
-          </a:fontRef>
-        </p:style>
-        <p:txBody>
-          <a:bodyPr rtlCol="0" anchor="ctr"/>
-          <a:lstStyle/>
-          <a:p/>
-        </p:txBody>
-      </p:sp>
-      <p:sp>
-        <p:nvSpPr>
-          <p:cNvPr id="17" name="Takeaways number 3"/>
-          <p:cNvSpPr/>
-          <p:nvPr/>
-        </p:nvSpPr>
-        <p:spPr>
-          <a:xfrm>
-            <a:off x="594360" y="2706624"/>
-            <a:ext cx="310896" cy="310896"/>
-          </a:xfrm>
-          <a:prstGeom prst="ellipse">
-            <a:avLst/>
-          </a:prstGeom>
-          <a:solidFill>
-            <a:schemeClr val="tx2"/>
-          </a:solidFill>
-          <a:ln>
-            <a:noFill/>
-          </a:ln>
-          <a:effectLst/>
-        </p:spPr>
-        <p:style>
-          <a:lnRef idx="1">
-            <a:schemeClr val="accent1"/>
-          </a:lnRef>
-          <a:fillRef idx="3">
-            <a:schemeClr val="accent1"/>
-          </a:fillRef>
-          <a:effectRef idx="2">
-            <a:schemeClr val="accent1"/>
-          </a:effectRef>
-          <a:fontRef idx="minor">
-            <a:schemeClr val="lt1"/>
-          </a:fontRef>
-        </p:style>
-        <p:txBody>
-          <a:bodyPr rtlCol="0" anchor="ctr" lIns="0" rIns="0" tIns="0" bIns="0"/>
-          <a:lstStyle/>
-          <a:p>
-            <a:pPr algn="ctr"/>
-            <a:r>
-              <a:rPr sz="1200" b="1" lang="en-GB">
+              <a:t>The manager asks: </a:t>
+            </a:r>
+            <a:r>
+              <a:rPr sz="1250" b="0" lang="en-GB">
                 <a:solidFill>
                   <a:schemeClr val="bg1"/>
                 </a:solidFill>
               </a:rPr>
-              <a:t>3</a:t>
-            </a:r>
-          </a:p>
-        </p:txBody>
-      </p:sp>
-      <p:sp>
-        <p:nvSpPr>
-          <p:cNvPr id="18" name="Takeaways text 3"/>
-          <p:cNvSpPr txBox="1"/>
-          <p:nvPr/>
-        </p:nvSpPr>
-        <p:spPr>
-          <a:xfrm>
-            <a:off x="1051560" y="2569464"/>
-            <a:ext cx="7498080" cy="585216"/>
-          </a:xfrm>
-          <a:prstGeom prst="rect">
-            <a:avLst/>
-          </a:prstGeom>
-          <a:noFill/>
-        </p:spPr>
-        <p:txBody>
-          <a:bodyPr wrap="square" lIns="0" rIns="0" tIns="0" bIns="0" anchor="ctr">
-            <a:noAutofit/>
-          </a:bodyPr>
-          <a:lstStyle/>
-          <a:p>
-            <a:pPr algn="l">
-              <a:spcAft>
-                <a:spcPts val="400"/>
-              </a:spcAft>
-            </a:pPr>
-            <a:r>
-              <a:rPr sz="1200" b="1" lang="en-GB">
-                <a:solidFill>
-                  <a:schemeClr val="tx2"/>
-                </a:solidFill>
-              </a:rPr>
-              <a:t>Dummies: </a:t>
-            </a:r>
-            <a:r>
-              <a:rPr sz="1200" b="0" lang="en-GB">
-                <a:solidFill>
-                  <a:schemeClr val="tx1"/>
-                </a:solidFill>
-              </a:rPr>
-              <a:t>k − 1 for k groups; each b is a difference to the reference; count the 1s</a:t>
-            </a:r>
-          </a:p>
-        </p:txBody>
-      </p:sp>
-      <p:sp>
-        <p:nvSpPr>
-          <p:cNvPr id="19" name="Takeaways row 4"/>
-          <p:cNvSpPr/>
-          <p:nvPr/>
-        </p:nvSpPr>
-        <p:spPr>
-          <a:xfrm>
-            <a:off x="457200" y="3236976"/>
-            <a:ext cx="8229600" cy="585216"/>
-          </a:xfrm>
-          <a:prstGeom prst="rect">
-            <a:avLst/>
-          </a:prstGeom>
-          <a:solidFill>
-            <a:schemeClr val="bg2"/>
-          </a:solidFill>
-          <a:ln>
-            <a:noFill/>
-          </a:ln>
-          <a:effectLst/>
-        </p:spPr>
-        <p:style>
-          <a:lnRef idx="1">
-            <a:schemeClr val="accent1"/>
-          </a:lnRef>
-          <a:fillRef idx="3">
-            <a:schemeClr val="accent1"/>
-          </a:fillRef>
-          <a:effectRef idx="2">
-            <a:schemeClr val="accent1"/>
-          </a:effectRef>
-          <a:fontRef idx="minor">
-            <a:schemeClr val="lt1"/>
-          </a:fontRef>
-        </p:style>
-        <p:txBody>
-          <a:bodyPr rtlCol="0" anchor="ctr"/>
-          <a:lstStyle/>
-          <a:p/>
-        </p:txBody>
-      </p:sp>
-      <p:sp>
-        <p:nvSpPr>
-          <p:cNvPr id="20" name="Takeaways number 4"/>
-          <p:cNvSpPr/>
-          <p:nvPr/>
-        </p:nvSpPr>
-        <p:spPr>
-          <a:xfrm>
-            <a:off x="594360" y="3374136"/>
-            <a:ext cx="310896" cy="310896"/>
-          </a:xfrm>
-          <a:prstGeom prst="ellipse">
-            <a:avLst/>
-          </a:prstGeom>
-          <a:solidFill>
-            <a:schemeClr val="tx2"/>
-          </a:solidFill>
-          <a:ln>
-            <a:noFill/>
-          </a:ln>
-          <a:effectLst/>
-        </p:spPr>
-        <p:style>
-          <a:lnRef idx="1">
-            <a:schemeClr val="accent1"/>
-          </a:lnRef>
-          <a:fillRef idx="3">
-            <a:schemeClr val="accent1"/>
-          </a:fillRef>
-          <a:effectRef idx="2">
-            <a:schemeClr val="accent1"/>
-          </a:effectRef>
-          <a:fontRef idx="minor">
-            <a:schemeClr val="lt1"/>
-          </a:fontRef>
-        </p:style>
-        <p:txBody>
-          <a:bodyPr rtlCol="0" anchor="ctr" lIns="0" rIns="0" tIns="0" bIns="0"/>
-          <a:lstStyle/>
-          <a:p>
-            <a:pPr algn="ctr"/>
-            <a:r>
-              <a:rPr sz="1200" b="1" lang="en-GB">
-                <a:solidFill>
-                  <a:schemeClr val="bg1"/>
-                </a:solidFill>
-              </a:rPr>
-              <a:t>4</a:t>
-            </a:r>
-          </a:p>
-        </p:txBody>
-      </p:sp>
-      <p:sp>
-        <p:nvSpPr>
-          <p:cNvPr id="21" name="Takeaways text 4"/>
-          <p:cNvSpPr txBox="1"/>
-          <p:nvPr/>
-        </p:nvSpPr>
-        <p:spPr>
-          <a:xfrm>
-            <a:off x="1051560" y="3236976"/>
-            <a:ext cx="7498080" cy="585216"/>
-          </a:xfrm>
-          <a:prstGeom prst="rect">
-            <a:avLst/>
-          </a:prstGeom>
-          <a:noFill/>
-        </p:spPr>
-        <p:txBody>
-          <a:bodyPr wrap="square" lIns="0" rIns="0" tIns="0" bIns="0" anchor="ctr">
-            <a:noAutofit/>
-          </a:bodyPr>
-          <a:lstStyle/>
-          <a:p>
-            <a:pPr algn="l">
-              <a:spcAft>
-                <a:spcPts val="400"/>
-              </a:spcAft>
-            </a:pPr>
-            <a:r>
-              <a:rPr sz="1200" b="1" lang="en-GB">
-                <a:solidFill>
-                  <a:schemeClr val="tx2"/>
-                </a:solidFill>
-              </a:rPr>
-              <a:t>Logs: </a:t>
-            </a:r>
-            <a:r>
-              <a:rPr sz="1200" b="0" lang="en-GB">
-                <a:solidFill>
-                  <a:schemeClr val="tx1"/>
-                </a:solidFill>
-              </a:rPr>
-              <a:t>elasticities, per cent effects, better residuals; compare models by tests, not R²</a:t>
-            </a:r>
-          </a:p>
-        </p:txBody>
-      </p:sp>
-      <p:sp>
-        <p:nvSpPr>
-          <p:cNvPr id="22" name="Takeaways row 5"/>
-          <p:cNvSpPr/>
-          <p:nvPr/>
-        </p:nvSpPr>
-        <p:spPr>
-          <a:xfrm>
-            <a:off x="457200" y="3904488"/>
-            <a:ext cx="8229600" cy="585216"/>
-          </a:xfrm>
-          <a:prstGeom prst="rect">
-            <a:avLst/>
-          </a:prstGeom>
-          <a:solidFill>
-            <a:schemeClr val="bg2"/>
-          </a:solidFill>
-          <a:ln>
-            <a:noFill/>
-          </a:ln>
-          <a:effectLst/>
-        </p:spPr>
-        <p:style>
-          <a:lnRef idx="1">
-            <a:schemeClr val="accent1"/>
-          </a:lnRef>
-          <a:fillRef idx="3">
-            <a:schemeClr val="accent1"/>
-          </a:fillRef>
-          <a:effectRef idx="2">
-            <a:schemeClr val="accent1"/>
-          </a:effectRef>
-          <a:fontRef idx="minor">
-            <a:schemeClr val="lt1"/>
-          </a:fontRef>
-        </p:style>
-        <p:txBody>
-          <a:bodyPr rtlCol="0" anchor="ctr"/>
-          <a:lstStyle/>
-          <a:p/>
-        </p:txBody>
-      </p:sp>
-      <p:sp>
-        <p:nvSpPr>
-          <p:cNvPr id="23" name="Takeaways number 5"/>
-          <p:cNvSpPr/>
-          <p:nvPr/>
-        </p:nvSpPr>
-        <p:spPr>
-          <a:xfrm>
-            <a:off x="594360" y="4041648"/>
-            <a:ext cx="310896" cy="310896"/>
-          </a:xfrm>
-          <a:prstGeom prst="ellipse">
-            <a:avLst/>
-          </a:prstGeom>
-          <a:solidFill>
-            <a:schemeClr val="tx2"/>
-          </a:solidFill>
-          <a:ln>
-            <a:noFill/>
-          </a:ln>
-          <a:effectLst/>
-        </p:spPr>
-        <p:style>
-          <a:lnRef idx="1">
-            <a:schemeClr val="accent1"/>
-          </a:lnRef>
-          <a:fillRef idx="3">
-            <a:schemeClr val="accent1"/>
-          </a:fillRef>
-          <a:effectRef idx="2">
-            <a:schemeClr val="accent1"/>
-          </a:effectRef>
-          <a:fontRef idx="minor">
-            <a:schemeClr val="lt1"/>
-          </a:fontRef>
-        </p:style>
-        <p:txBody>
-          <a:bodyPr rtlCol="0" anchor="ctr" lIns="0" rIns="0" tIns="0" bIns="0"/>
-          <a:lstStyle/>
-          <a:p>
-            <a:pPr algn="ctr"/>
-            <a:r>
-              <a:rPr sz="1200" b="1" lang="en-GB">
-                <a:solidFill>
-                  <a:schemeClr val="bg1"/>
-                </a:solidFill>
-              </a:rPr>
-              <a:t>5</a:t>
-            </a:r>
-          </a:p>
-        </p:txBody>
-      </p:sp>
-      <p:sp>
-        <p:nvSpPr>
-          <p:cNvPr id="24" name="Takeaways text 5"/>
-          <p:cNvSpPr txBox="1"/>
-          <p:nvPr/>
-        </p:nvSpPr>
-        <p:spPr>
-          <a:xfrm>
-            <a:off x="1051560" y="3904488"/>
-            <a:ext cx="7498080" cy="585216"/>
-          </a:xfrm>
-          <a:prstGeom prst="rect">
-            <a:avLst/>
-          </a:prstGeom>
-          <a:noFill/>
-        </p:spPr>
-        <p:txBody>
-          <a:bodyPr wrap="square" lIns="0" rIns="0" tIns="0" bIns="0" anchor="ctr">
-            <a:noAutofit/>
-          </a:bodyPr>
-          <a:lstStyle/>
-          <a:p>
-            <a:pPr algn="l">
-              <a:spcAft>
-                <a:spcPts val="400"/>
-              </a:spcAft>
-            </a:pPr>
-            <a:r>
-              <a:rPr sz="1200" b="1" lang="en-GB">
-                <a:solidFill>
-                  <a:schemeClr val="tx2"/>
-                </a:solidFill>
-              </a:rPr>
-              <a:t>Curves: </a:t>
-            </a:r>
-            <a:r>
-              <a:rPr sz="1200" b="0" lang="en-GB">
-                <a:solidFill>
-                  <a:schemeClr val="tx1"/>
-                </a:solidFill>
-              </a:rPr>
-              <a:t>squares and logs keep OLS linear in b; never read a curve beyond the data</a:t>
-            </a:r>
-          </a:p>
-        </p:txBody>
-      </p:sp>
-      <p:sp>
-        <p:nvSpPr>
-          <p:cNvPr id="25" name="Takeaway next box"/>
-          <p:cNvSpPr/>
-          <p:nvPr/>
-        </p:nvSpPr>
-        <p:spPr>
-          <a:xfrm>
-            <a:off x="457200" y="4572000"/>
-            <a:ext cx="8229600" cy="457200"/>
-          </a:xfrm>
-          <a:prstGeom prst="rect">
-            <a:avLst/>
-          </a:prstGeom>
-          <a:solidFill>
-            <a:schemeClr val="tx2"/>
-          </a:solidFill>
-          <a:ln>
-            <a:noFill/>
-          </a:ln>
-          <a:effectLst/>
-        </p:spPr>
-        <p:style>
-          <a:lnRef idx="1">
-            <a:schemeClr val="accent1"/>
-          </a:lnRef>
-          <a:fillRef idx="3">
-            <a:schemeClr val="accent1"/>
-          </a:fillRef>
-          <a:effectRef idx="2">
-            <a:schemeClr val="accent1"/>
-          </a:effectRef>
-          <a:fontRef idx="minor">
-            <a:schemeClr val="lt1"/>
-          </a:fontRef>
-        </p:style>
-        <p:txBody>
-          <a:bodyPr rtlCol="0" anchor="ctr"/>
-          <a:lstStyle/>
-          <a:p/>
-        </p:txBody>
-      </p:sp>
-      <p:pic>
-        <p:nvPicPr>
-          <p:cNvPr id="26" name="Icon Takeaway next" descr=""/>
-          <p:cNvPicPr>
-            <a:picLocks noChangeAspect="1"/>
-          </p:cNvPicPr>
-          <p:nvPr/>
-        </p:nvPicPr>
-        <p:blipFill>
-          <a:blip r:embed="rId3"/>
-          <a:stretch>
-            <a:fillRect/>
-          </a:stretch>
-        </p:blipFill>
-        <p:spPr>
-          <a:xfrm>
-            <a:off x="658368" y="4617720"/>
-            <a:ext cx="365760" cy="365760"/>
-          </a:xfrm>
-          <a:prstGeom prst="rect">
-            <a:avLst/>
-          </a:prstGeom>
-        </p:spPr>
-      </p:pic>
-      <p:sp>
-        <p:nvSpPr>
-          <p:cNvPr id="27" name="Takeaway next text"/>
-          <p:cNvSpPr txBox="1"/>
-          <p:nvPr/>
-        </p:nvSpPr>
-        <p:spPr>
-          <a:xfrm>
-            <a:off x="1207008" y="4572000"/>
-            <a:ext cx="7315200" cy="457200"/>
-          </a:xfrm>
-          <a:prstGeom prst="rect">
-            <a:avLst/>
-          </a:prstGeom>
-          <a:noFill/>
-        </p:spPr>
-        <p:txBody>
-          <a:bodyPr wrap="square" lIns="0" rIns="0" tIns="0" bIns="0" anchor="ctr">
-            <a:noAutofit/>
-          </a:bodyPr>
-          <a:lstStyle/>
-          <a:p>
-            <a:pPr algn="l">
-              <a:spcAft>
-                <a:spcPts val="400"/>
-              </a:spcAft>
-            </a:pPr>
-            <a:r>
-              <a:rPr sz="1200" b="1" lang="en-GB">
-                <a:solidFill>
-                  <a:schemeClr val="bg1"/>
-                </a:solidFill>
-              </a:rPr>
-              <a:t>Homework: </a:t>
-            </a:r>
-            <a:r>
-              <a:rPr sz="1200" b="0" lang="en-GB">
-                <a:solidFill>
-                  <a:schemeClr val="bg1"/>
-                </a:solidFill>
-              </a:rPr>
-              <a:t>coding exercise 2 with your personal data, brief on Canvas.</a:t>
+              <a:t>where do page views turn into sales, and should we invest in Switzerland?</a:t>
             </a:r>
           </a:p>
         </p:txBody>
@@ -44620,7 +44606,7 @@
           <a:p>
             <a:r>
               <a:rPr sz="1600" lang="en-GB"/>
-              <a:t>References</a:t>
+              <a:t>Your turn: the fashion brand in Python</a:t>
             </a:r>
           </a:p>
         </p:txBody>
@@ -44676,122 +44662,19 @@
       </p:sp>
       <p:sp>
         <p:nvSpPr>
-          <p:cNvPr id="10" name="Ref 1 header"/>
+          <p:cNvPr id="10" name="Fashion steps step 1"/>
           <p:cNvSpPr/>
           <p:nvPr/>
         </p:nvSpPr>
         <p:spPr>
           <a:xfrm>
             <a:off x="457200" y="1234440"/>
-            <a:ext cx="4046220" cy="411480"/>
-          </a:xfrm>
-          <a:prstGeom prst="rect">
-            <a:avLst/>
-          </a:prstGeom>
-          <a:solidFill>
-            <a:schemeClr val="accent1"/>
-          </a:solidFill>
-          <a:ln>
-            <a:noFill/>
-          </a:ln>
-          <a:effectLst/>
-        </p:spPr>
-        <p:style>
-          <a:lnRef idx="1">
-            <a:schemeClr val="accent1"/>
-          </a:lnRef>
-          <a:fillRef idx="3">
-            <a:schemeClr val="accent1"/>
-          </a:fillRef>
-          <a:effectRef idx="2">
-            <a:schemeClr val="accent1"/>
-          </a:effectRef>
-          <a:fontRef idx="minor">
-            <a:schemeClr val="lt1"/>
-          </a:fontRef>
-        </p:style>
-        <p:txBody>
-          <a:bodyPr rtlCol="0" anchor="ctr"/>
-          <a:lstStyle/>
-          <a:p/>
-        </p:txBody>
-      </p:sp>
-      <p:sp>
-        <p:nvSpPr>
-          <p:cNvPr id="11" name="Ref 1 heading"/>
-          <p:cNvSpPr txBox="1"/>
-          <p:nvPr/>
-        </p:nvSpPr>
-        <p:spPr>
-          <a:xfrm>
-            <a:off x="594360" y="1234440"/>
-            <a:ext cx="3360420" cy="411480"/>
-          </a:xfrm>
-          <a:prstGeom prst="rect">
-            <a:avLst/>
-          </a:prstGeom>
-          <a:noFill/>
-        </p:spPr>
-        <p:txBody>
-          <a:bodyPr wrap="square" lIns="0" rIns="0" tIns="0" bIns="0" anchor="ctr">
-            <a:noAutofit/>
-          </a:bodyPr>
-          <a:lstStyle/>
-          <a:p>
-            <a:pPr algn="l">
-              <a:spcAft>
-                <a:spcPts val="400"/>
-              </a:spcAft>
-            </a:pPr>
-            <a:r>
-              <a:rPr sz="1500" b="1" lang="en-GB">
-                <a:solidFill>
-                  <a:schemeClr val="bg1"/>
-                </a:solidFill>
-                <a:latin typeface="+mj-lt"/>
-              </a:rPr>
-              <a:t>Academic</a:t>
-            </a:r>
-          </a:p>
-        </p:txBody>
-      </p:sp>
-      <p:pic>
-        <p:nvPicPr>
-          <p:cNvPr id="12" name="Icon ref 1" descr=""/>
-          <p:cNvPicPr>
-            <a:picLocks noChangeAspect="1"/>
-          </p:cNvPicPr>
-          <p:nvPr/>
-        </p:nvPicPr>
-        <p:blipFill>
-          <a:blip r:embed="rId3"/>
-          <a:stretch>
-            <a:fillRect/>
-          </a:stretch>
-        </p:blipFill>
-        <p:spPr>
-          <a:xfrm>
-            <a:off x="4064508" y="1280160"/>
-            <a:ext cx="310896" cy="310896"/>
-          </a:xfrm>
-          <a:prstGeom prst="rect">
-            <a:avLst/>
-          </a:prstGeom>
-        </p:spPr>
-      </p:pic>
-      <p:sp>
-        <p:nvSpPr>
-          <p:cNvPr id="13" name="Ref 1 body"/>
-          <p:cNvSpPr/>
-          <p:nvPr/>
-        </p:nvSpPr>
-        <p:spPr>
-          <a:xfrm>
-            <a:off x="457200" y="1645920"/>
-            <a:ext cx="4046220" cy="3429000"/>
-          </a:xfrm>
-          <a:prstGeom prst="rect">
-            <a:avLst/>
+            <a:ext cx="2816352" cy="457200"/>
+          </a:xfrm>
+          <a:prstGeom prst="homePlate">
+            <a:avLst>
+              <a:gd name="adj" fmla="val 28000"/>
+            </a:avLst>
           </a:prstGeom>
           <a:solidFill>
             <a:schemeClr val="bg2"/>
@@ -44816,267 +44699,45 @@
           </a:fontRef>
         </p:style>
         <p:txBody>
-          <a:bodyPr rtlCol="0" anchor="ctr"/>
-          <a:lstStyle/>
-          <a:p/>
-        </p:txBody>
-      </p:sp>
-      <p:sp>
-        <p:nvSpPr>
-          <p:cNvPr id="14" name="Ref 1 text"/>
-          <p:cNvSpPr txBox="1"/>
-          <p:nvPr/>
-        </p:nvSpPr>
-        <p:spPr>
-          <a:xfrm>
-            <a:off x="621792" y="1737360"/>
-            <a:ext cx="3744468" cy="3291840"/>
-          </a:xfrm>
-          <a:prstGeom prst="rect">
-            <a:avLst/>
-          </a:prstGeom>
-          <a:noFill/>
-        </p:spPr>
-        <p:txBody>
-          <a:bodyPr wrap="square" lIns="0" rIns="0" tIns="0" bIns="0" anchor="t">
-            <a:noAutofit/>
-          </a:bodyPr>
-          <a:lstStyle/>
-          <a:p>
-            <a:pPr algn="l">
-              <a:spcAft>
-                <a:spcPts val="500"/>
-              </a:spcAft>
-            </a:pPr>
-            <a:r>
-              <a:rPr sz="1100" b="1" lang="en-GB">
+          <a:bodyPr rtlCol="0" anchor="ctr" wrap="square" rIns="128016" tIns="18288" bIns="18288"/>
+          <a:lstStyle/>
+          <a:p>
+            <a:pPr algn="ctr"/>
+            <a:r>
+              <a:rPr sz="1200" b="1" lang="en-GB">
                 <a:solidFill>
                   <a:schemeClr val="tx2"/>
                 </a:solidFill>
               </a:rPr>
-              <a:t>Skiera, B., Reiner, J. &amp; Albers, S. (2022). </a:t>
-            </a:r>
-            <a:r>
-              <a:rPr sz="1100" b="0" lang="en-GB">
-                <a:solidFill>
-                  <a:schemeClr val="tx1"/>
-                </a:solidFill>
-              </a:rPr>
-              <a:t>Regression analysis. In Homburg et al. (eds), Handbook of Market Research, 299–327. Springer.</a:t>
-            </a:r>
-          </a:p>
-          <a:p>
-            <a:pPr algn="l">
-              <a:spcAft>
-                <a:spcPts val="500"/>
-              </a:spcAft>
-            </a:pPr>
-            <a:r>
-              <a:rPr sz="1100" b="1" lang="en-GB">
+              <a:t>Pairs, with packages:</a:t>
+            </a:r>
+            <a:br/>
+            <a:r>
+              <a:rPr sz="1200" b="1" lang="en-GB">
                 <a:solidFill>
                   <a:schemeClr val="tx2"/>
                 </a:solidFill>
               </a:rPr>
-              <a:t>Bojinov, I. I., Parzen, M. &amp; Hamilton, P. J. (2025). </a:t>
-            </a:r>
-            <a:r>
-              <a:rPr sz="1100" b="0" lang="en-GB">
-                <a:solidFill>
-                  <a:schemeClr val="tx1"/>
-                </a:solidFill>
-              </a:rPr>
-              <a:t>Linear Regression. HBS note 9-622-100 (Canvas).</a:t>
-            </a:r>
-          </a:p>
-          <a:p>
-            <a:pPr algn="l">
-              <a:spcAft>
-                <a:spcPts val="500"/>
-              </a:spcAft>
-            </a:pPr>
-            <a:r>
-              <a:rPr sz="1100" b="1" lang="en-GB">
-                <a:solidFill>
-                  <a:schemeClr val="tx2"/>
-                </a:solidFill>
-              </a:rPr>
-              <a:t>Wooldridge, J. M. (2025). </a:t>
-            </a:r>
-            <a:r>
-              <a:rPr sz="1100" b="0" lang="en-GB">
-                <a:solidFill>
-                  <a:schemeClr val="tx1"/>
-                </a:solidFill>
-              </a:rPr>
-              <a:t>Introductory Econometrics, 8th ed. Cengage. Ch. 6 to 9.</a:t>
-            </a:r>
-          </a:p>
-          <a:p>
-            <a:pPr algn="l">
-              <a:spcAft>
-                <a:spcPts val="500"/>
-              </a:spcAft>
-            </a:pPr>
-            <a:r>
-              <a:rPr sz="1100" b="1" lang="en-GB">
-                <a:solidFill>
-                  <a:schemeClr val="tx2"/>
-                </a:solidFill>
-              </a:rPr>
-              <a:t>Hanssens, D. M., Parsons, L. J. &amp; Schultz, R. L. (2001). </a:t>
-            </a:r>
-            <a:r>
-              <a:rPr sz="1100" b="0" lang="en-GB">
-                <a:solidFill>
-                  <a:schemeClr val="tx1"/>
-                </a:solidFill>
-              </a:rPr>
-              <a:t>Market Response Models. Kluwer.</a:t>
-            </a:r>
-          </a:p>
-          <a:p>
-            <a:pPr algn="l">
-              <a:spcAft>
-                <a:spcPts val="500"/>
-              </a:spcAft>
-            </a:pPr>
-            <a:r>
-              <a:rPr sz="1100" b="1" lang="en-GB">
-                <a:solidFill>
-                  <a:schemeClr val="tx2"/>
-                </a:solidFill>
-              </a:rPr>
-              <a:t>Hair, J. F. et al. (2019). </a:t>
-            </a:r>
-            <a:r>
-              <a:rPr sz="1100" b="0" lang="en-GB">
-                <a:solidFill>
-                  <a:schemeClr val="tx1"/>
-                </a:solidFill>
-              </a:rPr>
-              <a:t>Multivariate Data Analysis, 8th ed. Cengage. Ch. 5.</a:t>
-            </a:r>
-          </a:p>
-        </p:txBody>
-      </p:sp>
-      <p:sp>
-        <p:nvSpPr>
-          <p:cNvPr id="15" name="Ref 2 header"/>
+              <a:t>20 minutes</a:t>
+            </a:r>
+          </a:p>
+        </p:txBody>
+      </p:sp>
+      <p:sp>
+        <p:nvSpPr>
+          <p:cNvPr id="11" name="Fashion steps step 2"/>
           <p:cNvSpPr/>
           <p:nvPr/>
         </p:nvSpPr>
         <p:spPr>
           <a:xfrm>
-            <a:off x="4640580" y="1234440"/>
-            <a:ext cx="4046220" cy="411480"/>
-          </a:xfrm>
-          <a:prstGeom prst="rect">
-            <a:avLst/>
-          </a:prstGeom>
-          <a:solidFill>
-            <a:schemeClr val="accent1"/>
-          </a:solidFill>
-          <a:ln>
-            <a:noFill/>
-          </a:ln>
-          <a:effectLst/>
-        </p:spPr>
-        <p:style>
-          <a:lnRef idx="1">
-            <a:schemeClr val="accent1"/>
-          </a:lnRef>
-          <a:fillRef idx="3">
-            <a:schemeClr val="accent1"/>
-          </a:fillRef>
-          <a:effectRef idx="2">
-            <a:schemeClr val="accent1"/>
-          </a:effectRef>
-          <a:fontRef idx="minor">
-            <a:schemeClr val="lt1"/>
-          </a:fontRef>
-        </p:style>
-        <p:txBody>
-          <a:bodyPr rtlCol="0" anchor="ctr"/>
-          <a:lstStyle/>
-          <a:p/>
-        </p:txBody>
-      </p:sp>
-      <p:sp>
-        <p:nvSpPr>
-          <p:cNvPr id="16" name="Ref 2 heading"/>
-          <p:cNvSpPr txBox="1"/>
-          <p:nvPr/>
-        </p:nvSpPr>
-        <p:spPr>
-          <a:xfrm>
-            <a:off x="4777740" y="1234440"/>
-            <a:ext cx="3360420" cy="411480"/>
-          </a:xfrm>
-          <a:prstGeom prst="rect">
-            <a:avLst/>
-          </a:prstGeom>
-          <a:noFill/>
-        </p:spPr>
-        <p:txBody>
-          <a:bodyPr wrap="square" lIns="0" rIns="0" tIns="0" bIns="0" anchor="ctr">
-            <a:noAutofit/>
-          </a:bodyPr>
-          <a:lstStyle/>
-          <a:p>
-            <a:pPr algn="l">
-              <a:spcAft>
-                <a:spcPts val="400"/>
-              </a:spcAft>
-            </a:pPr>
-            <a:r>
-              <a:rPr sz="1500" b="1" lang="en-GB">
-                <a:solidFill>
-                  <a:schemeClr val="bg1"/>
-                </a:solidFill>
-                <a:latin typeface="+mj-lt"/>
-              </a:rPr>
-              <a:t>Learning resources</a:t>
-            </a:r>
-          </a:p>
-        </p:txBody>
-      </p:sp>
-      <p:pic>
-        <p:nvPicPr>
-          <p:cNvPr id="17" name="Icon ref 2" descr=""/>
-          <p:cNvPicPr>
-            <a:picLocks noChangeAspect="1"/>
-          </p:cNvPicPr>
-          <p:nvPr/>
-        </p:nvPicPr>
-        <p:blipFill>
-          <a:blip r:embed="rId4"/>
-          <a:stretch>
-            <a:fillRect/>
-          </a:stretch>
-        </p:blipFill>
-        <p:spPr>
-          <a:xfrm>
-            <a:off x="8247888" y="1280160"/>
-            <a:ext cx="310896" cy="310896"/>
-          </a:xfrm>
-          <a:prstGeom prst="rect">
-            <a:avLst/>
-          </a:prstGeom>
-        </p:spPr>
-      </p:pic>
-      <p:sp>
-        <p:nvSpPr>
-          <p:cNvPr id="18" name="Ref 2 body"/>
-          <p:cNvSpPr/>
-          <p:nvPr/>
-        </p:nvSpPr>
-        <p:spPr>
-          <a:xfrm>
-            <a:off x="4640580" y="1645920"/>
-            <a:ext cx="4046220" cy="3429000"/>
-          </a:xfrm>
-          <a:prstGeom prst="rect">
-            <a:avLst/>
+            <a:off x="3163824" y="1234440"/>
+            <a:ext cx="2816352" cy="457200"/>
+          </a:xfrm>
+          <a:prstGeom prst="chevron">
+            <a:avLst>
+              <a:gd name="adj" fmla="val 28000"/>
+            </a:avLst>
           </a:prstGeom>
           <a:solidFill>
             <a:schemeClr val="bg2"/>
@@ -45101,6 +44762,130 @@
           </a:fontRef>
         </p:style>
         <p:txBody>
+          <a:bodyPr rtlCol="0" anchor="ctr" wrap="square" lIns="237744" rIns="128016" tIns="18288" bIns="18288"/>
+          <a:lstStyle/>
+          <a:p>
+            <a:pPr algn="ctr"/>
+            <a:r>
+              <a:rPr sz="1200" b="1" lang="en-GB">
+                <a:solidFill>
+                  <a:schemeClr val="tx2"/>
+                </a:solidFill>
+              </a:rPr>
+              <a:t>Plenary, answers:</a:t>
+            </a:r>
+            <a:br/>
+            <a:r>
+              <a:rPr sz="1200" b="1" lang="en-GB">
+                <a:solidFill>
+                  <a:schemeClr val="tx2"/>
+                </a:solidFill>
+              </a:rPr>
+              <a:t>5 minutes</a:t>
+            </a:r>
+          </a:p>
+        </p:txBody>
+      </p:sp>
+      <p:sp>
+        <p:nvSpPr>
+          <p:cNvPr id="12" name="Fashion steps step 3"/>
+          <p:cNvSpPr/>
+          <p:nvPr/>
+        </p:nvSpPr>
+        <p:spPr>
+          <a:xfrm>
+            <a:off x="5870448" y="1234440"/>
+            <a:ext cx="2816352" cy="457200"/>
+          </a:xfrm>
+          <a:prstGeom prst="chevron">
+            <a:avLst>
+              <a:gd name="adj" fmla="val 28000"/>
+            </a:avLst>
+          </a:prstGeom>
+          <a:solidFill>
+            <a:schemeClr val="bg2"/>
+          </a:solidFill>
+          <a:ln>
+            <a:noFill/>
+          </a:ln>
+          <a:effectLst/>
+        </p:spPr>
+        <p:style>
+          <a:lnRef idx="1">
+            <a:schemeClr val="accent1"/>
+          </a:lnRef>
+          <a:fillRef idx="3">
+            <a:schemeClr val="accent1"/>
+          </a:fillRef>
+          <a:effectRef idx="2">
+            <a:schemeClr val="accent1"/>
+          </a:effectRef>
+          <a:fontRef idx="minor">
+            <a:schemeClr val="lt1"/>
+          </a:fontRef>
+        </p:style>
+        <p:txBody>
+          <a:bodyPr rtlCol="0" anchor="ctr" wrap="square" lIns="237744" rIns="128016" tIns="18288" bIns="18288"/>
+          <a:lstStyle/>
+          <a:p>
+            <a:pPr algn="ctr"/>
+            <a:r>
+              <a:rPr sz="1200" b="1" lang="en-GB">
+                <a:solidFill>
+                  <a:schemeClr val="tx2"/>
+                </a:solidFill>
+              </a:rPr>
+              <a:t>Posit Assistant:</a:t>
+            </a:r>
+            <a:br/>
+            <a:r>
+              <a:rPr sz="1200" b="1" lang="en-GB">
+                <a:solidFill>
+                  <a:schemeClr val="tx2"/>
+                </a:solidFill>
+              </a:rPr>
+              <a:t>10 minutes</a:t>
+            </a:r>
+          </a:p>
+        </p:txBody>
+      </p:sp>
+      <p:sp>
+        <p:nvSpPr>
+          <p:cNvPr id="13" name="Fashion q row 1"/>
+          <p:cNvSpPr/>
+          <p:nvPr/>
+        </p:nvSpPr>
+        <p:spPr>
+          <a:xfrm>
+            <a:off x="457200" y="1828800"/>
+            <a:ext cx="8229600" cy="457200"/>
+          </a:xfrm>
+          <a:prstGeom prst="rect">
+            <a:avLst/>
+          </a:prstGeom>
+          <a:solidFill>
+            <a:schemeClr val="bg2"/>
+          </a:solidFill>
+          <a:ln>
+            <a:noFill/>
+          </a:ln>
+          <a:effectLst/>
+        </p:spPr>
+        <p:style>
+          <a:lnRef idx="1">
+            <a:schemeClr val="accent1"/>
+          </a:lnRef>
+          <a:fillRef idx="3">
+            <a:schemeClr val="accent1"/>
+          </a:fillRef>
+          <a:effectRef idx="2">
+            <a:schemeClr val="accent1"/>
+          </a:effectRef>
+          <a:fontRef idx="minor">
+            <a:schemeClr val="lt1"/>
+          </a:fontRef>
+        </p:style>
+        <p:txBody>
           <a:bodyPr rtlCol="0" anchor="ctr"/>
           <a:lstStyle/>
           <a:p/>
@@ -45108,14 +44893,66 @@
       </p:sp>
       <p:sp>
         <p:nvSpPr>
-          <p:cNvPr id="19" name="Ref 2 text"/>
+          <p:cNvPr id="14" name="Fashion q number 1"/>
+          <p:cNvSpPr/>
+          <p:nvPr/>
+        </p:nvSpPr>
+        <p:spPr>
+          <a:xfrm>
+            <a:off x="594360" y="1901952"/>
+            <a:ext cx="310896" cy="310896"/>
+          </a:xfrm>
+          <a:prstGeom prst="ellipse">
+            <a:avLst/>
+          </a:prstGeom>
+          <a:solidFill>
+            <a:schemeClr val="tx2"/>
+          </a:solidFill>
+          <a:ln>
+            <a:noFill/>
+          </a:ln>
+          <a:effectLst/>
+        </p:spPr>
+        <p:style>
+          <a:lnRef idx="1">
+            <a:schemeClr val="accent1"/>
+          </a:lnRef>
+          <a:fillRef idx="3">
+            <a:schemeClr val="accent1"/>
+          </a:fillRef>
+          <a:effectRef idx="2">
+            <a:schemeClr val="accent1"/>
+          </a:effectRef>
+          <a:fontRef idx="minor">
+            <a:schemeClr val="lt1"/>
+          </a:fontRef>
+        </p:style>
+        <p:txBody>
+          <a:bodyPr rtlCol="0" anchor="ctr" lIns="0" rIns="0" tIns="0" bIns="0"/>
+          <a:lstStyle/>
+          <a:p>
+            <a:pPr algn="ctr"/>
+            <a:r>
+              <a:rPr sz="1200" b="1" lang="en-GB">
+                <a:solidFill>
+                  <a:schemeClr val="bg1"/>
+                </a:solidFill>
+              </a:rPr>
+              <a:t>1</a:t>
+            </a:r>
+          </a:p>
+        </p:txBody>
+      </p:sp>
+      <p:sp>
+        <p:nvSpPr>
+          <p:cNvPr id="15" name="Fashion q text 1"/>
           <p:cNvSpPr txBox="1"/>
           <p:nvPr/>
         </p:nvSpPr>
         <p:spPr>
           <a:xfrm>
-            <a:off x="4805172" y="1737360"/>
-            <a:ext cx="3744468" cy="3291840"/>
+            <a:off x="1051560" y="1828800"/>
+            <a:ext cx="7498080" cy="457200"/>
           </a:xfrm>
           <a:prstGeom prst="rect">
             <a:avLst/>
@@ -45123,123 +44960,646 @@
           <a:noFill/>
         </p:spPr>
         <p:txBody>
-          <a:bodyPr wrap="square" lIns="0" rIns="0" tIns="0" bIns="0" anchor="t">
+          <a:bodyPr wrap="square" lIns="0" rIns="0" tIns="0" bIns="0" anchor="ctr">
             <a:noAutofit/>
           </a:bodyPr>
           <a:lstStyle/>
           <a:p>
             <a:pPr algn="l">
               <a:spcAft>
-                <a:spcPts val="500"/>
+                <a:spcPts val="400"/>
               </a:spcAft>
             </a:pPr>
             <a:r>
-              <a:rPr sz="1100" b="1" lang="en-GB">
+              <a:rPr sz="1200" b="1" lang="en-GB">
                 <a:solidFill>
                   <a:schemeClr val="tx2"/>
                 </a:solidFill>
               </a:rPr>
-              <a:t>James, G. et al. (2023). </a:t>
-            </a:r>
-            <a:r>
-              <a:rPr sz="1100" b="0" lang="en-GB">
+              <a:t>Markets: </a:t>
+            </a:r>
+            <a:r>
+              <a:rPr sz="1200" b="0" lang="en-GB">
                 <a:solidFill>
                   <a:schemeClr val="tx1"/>
                 </a:solidFill>
               </a:rPr>
-              <a:t>ISLP, ch. 3.3 and the Python lab (free).</a:t>
-            </a:r>
-          </a:p>
+              <a:t>SS26 by country: NMV, sales, sold per 100 views, return rate; a great_tables table</a:t>
+            </a:r>
+          </a:p>
+        </p:txBody>
+      </p:sp>
+      <p:sp>
+        <p:nvSpPr>
+          <p:cNvPr id="16" name="Fashion q row 2"/>
+          <p:cNvSpPr/>
+          <p:nvPr/>
+        </p:nvSpPr>
+        <p:spPr>
+          <a:xfrm>
+            <a:off x="457200" y="2350008"/>
+            <a:ext cx="8229600" cy="457200"/>
+          </a:xfrm>
+          <a:prstGeom prst="rect">
+            <a:avLst/>
+          </a:prstGeom>
+          <a:solidFill>
+            <a:schemeClr val="bg2"/>
+          </a:solidFill>
+          <a:ln>
+            <a:noFill/>
+          </a:ln>
+          <a:effectLst/>
+        </p:spPr>
+        <p:style>
+          <a:lnRef idx="1">
+            <a:schemeClr val="accent1"/>
+          </a:lnRef>
+          <a:fillRef idx="3">
+            <a:schemeClr val="accent1"/>
+          </a:fillRef>
+          <a:effectRef idx="2">
+            <a:schemeClr val="accent1"/>
+          </a:effectRef>
+          <a:fontRef idx="minor">
+            <a:schemeClr val="lt1"/>
+          </a:fontRef>
+        </p:style>
+        <p:txBody>
+          <a:bodyPr rtlCol="0" anchor="ctr"/>
+          <a:lstStyle/>
+          <a:p/>
+        </p:txBody>
+      </p:sp>
+      <p:sp>
+        <p:nvSpPr>
+          <p:cNvPr id="17" name="Fashion q number 2"/>
+          <p:cNvSpPr/>
+          <p:nvPr/>
+        </p:nvSpPr>
+        <p:spPr>
+          <a:xfrm>
+            <a:off x="594360" y="2423160"/>
+            <a:ext cx="310896" cy="310896"/>
+          </a:xfrm>
+          <a:prstGeom prst="ellipse">
+            <a:avLst/>
+          </a:prstGeom>
+          <a:solidFill>
+            <a:schemeClr val="tx2"/>
+          </a:solidFill>
+          <a:ln>
+            <a:noFill/>
+          </a:ln>
+          <a:effectLst/>
+        </p:spPr>
+        <p:style>
+          <a:lnRef idx="1">
+            <a:schemeClr val="accent1"/>
+          </a:lnRef>
+          <a:fillRef idx="3">
+            <a:schemeClr val="accent1"/>
+          </a:fillRef>
+          <a:effectRef idx="2">
+            <a:schemeClr val="accent1"/>
+          </a:effectRef>
+          <a:fontRef idx="minor">
+            <a:schemeClr val="lt1"/>
+          </a:fontRef>
+        </p:style>
+        <p:txBody>
+          <a:bodyPr rtlCol="0" anchor="ctr" lIns="0" rIns="0" tIns="0" bIns="0"/>
+          <a:lstStyle/>
+          <a:p>
+            <a:pPr algn="ctr"/>
+            <a:r>
+              <a:rPr sz="1200" b="1" lang="en-GB">
+                <a:solidFill>
+                  <a:schemeClr val="bg1"/>
+                </a:solidFill>
+              </a:rPr>
+              <a:t>2</a:t>
+            </a:r>
+          </a:p>
+        </p:txBody>
+      </p:sp>
+      <p:sp>
+        <p:nvSpPr>
+          <p:cNvPr id="18" name="Fashion q text 2"/>
+          <p:cNvSpPr txBox="1"/>
+          <p:nvPr/>
+        </p:nvSpPr>
+        <p:spPr>
+          <a:xfrm>
+            <a:off x="1051560" y="2350008"/>
+            <a:ext cx="7498080" cy="457200"/>
+          </a:xfrm>
+          <a:prstGeom prst="rect">
+            <a:avLst/>
+          </a:prstGeom>
+          <a:noFill/>
+        </p:spPr>
+        <p:txBody>
+          <a:bodyPr wrap="square" lIns="0" rIns="0" tIns="0" bIns="0" anchor="ctr">
+            <a:noAutofit/>
+          </a:bodyPr>
+          <a:lstStyle/>
           <a:p>
             <a:pPr algn="l">
               <a:spcAft>
-                <a:spcPts val="500"/>
+                <a:spcPts val="400"/>
               </a:spcAft>
             </a:pPr>
             <a:r>
-              <a:rPr sz="1100" b="1" lang="en-GB">
+              <a:rPr sz="1200" b="1" lang="en-GB">
                 <a:solidFill>
                   <a:schemeClr val="tx2"/>
                 </a:solidFill>
               </a:rPr>
-              <a:t>statsmodels. </a:t>
-            </a:r>
-            <a:r>
-              <a:rPr sz="1100" b="0" lang="en-GB">
+              <a:t>Funnel: </a:t>
+            </a:r>
+            <a:r>
+              <a:rPr sz="1200" b="0" lang="en-GB">
                 <a:solidFill>
                   <a:schemeClr val="tx1"/>
                 </a:solidFill>
               </a:rPr>
-              <a:t>Regression diagnostics and specification tests (documentation).</a:t>
-            </a:r>
-          </a:p>
+              <a:t>np.log(sold_articles) ~ np.log(pdp_views), rows with sales only; read the elasticity</a:t>
+            </a:r>
+          </a:p>
+        </p:txBody>
+      </p:sp>
+      <p:sp>
+        <p:nvSpPr>
+          <p:cNvPr id="19" name="Fashion q row 3"/>
+          <p:cNvSpPr/>
+          <p:nvPr/>
+        </p:nvSpPr>
+        <p:spPr>
+          <a:xfrm>
+            <a:off x="457200" y="2871216"/>
+            <a:ext cx="8229600" cy="457200"/>
+          </a:xfrm>
+          <a:prstGeom prst="rect">
+            <a:avLst/>
+          </a:prstGeom>
+          <a:solidFill>
+            <a:schemeClr val="bg2"/>
+          </a:solidFill>
+          <a:ln>
+            <a:noFill/>
+          </a:ln>
+          <a:effectLst/>
+        </p:spPr>
+        <p:style>
+          <a:lnRef idx="1">
+            <a:schemeClr val="accent1"/>
+          </a:lnRef>
+          <a:fillRef idx="3">
+            <a:schemeClr val="accent1"/>
+          </a:fillRef>
+          <a:effectRef idx="2">
+            <a:schemeClr val="accent1"/>
+          </a:effectRef>
+          <a:fontRef idx="minor">
+            <a:schemeClr val="lt1"/>
+          </a:fontRef>
+        </p:style>
+        <p:txBody>
+          <a:bodyPr rtlCol="0" anchor="ctr"/>
+          <a:lstStyle/>
+          <a:p/>
+        </p:txBody>
+      </p:sp>
+      <p:sp>
+        <p:nvSpPr>
+          <p:cNvPr id="20" name="Fashion q number 3"/>
+          <p:cNvSpPr/>
+          <p:nvPr/>
+        </p:nvSpPr>
+        <p:spPr>
+          <a:xfrm>
+            <a:off x="594360" y="2944368"/>
+            <a:ext cx="310896" cy="310896"/>
+          </a:xfrm>
+          <a:prstGeom prst="ellipse">
+            <a:avLst/>
+          </a:prstGeom>
+          <a:solidFill>
+            <a:schemeClr val="tx2"/>
+          </a:solidFill>
+          <a:ln>
+            <a:noFill/>
+          </a:ln>
+          <a:effectLst/>
+        </p:spPr>
+        <p:style>
+          <a:lnRef idx="1">
+            <a:schemeClr val="accent1"/>
+          </a:lnRef>
+          <a:fillRef idx="3">
+            <a:schemeClr val="accent1"/>
+          </a:fillRef>
+          <a:effectRef idx="2">
+            <a:schemeClr val="accent1"/>
+          </a:effectRef>
+          <a:fontRef idx="minor">
+            <a:schemeClr val="lt1"/>
+          </a:fontRef>
+        </p:style>
+        <p:txBody>
+          <a:bodyPr rtlCol="0" anchor="ctr" lIns="0" rIns="0" tIns="0" bIns="0"/>
+          <a:lstStyle/>
+          <a:p>
+            <a:pPr algn="ctr"/>
+            <a:r>
+              <a:rPr sz="1200" b="1" lang="en-GB">
+                <a:solidFill>
+                  <a:schemeClr val="bg1"/>
+                </a:solidFill>
+              </a:rPr>
+              <a:t>3</a:t>
+            </a:r>
+          </a:p>
+        </p:txBody>
+      </p:sp>
+      <p:sp>
+        <p:nvSpPr>
+          <p:cNvPr id="21" name="Fashion q text 3"/>
+          <p:cNvSpPr txBox="1"/>
+          <p:nvPr/>
+        </p:nvSpPr>
+        <p:spPr>
+          <a:xfrm>
+            <a:off x="1051560" y="2871216"/>
+            <a:ext cx="7498080" cy="457200"/>
+          </a:xfrm>
+          <a:prstGeom prst="rect">
+            <a:avLst/>
+          </a:prstGeom>
+          <a:noFill/>
+        </p:spPr>
+        <p:txBody>
+          <a:bodyPr wrap="square" lIns="0" rIns="0" tIns="0" bIns="0" anchor="ctr">
+            <a:noAutofit/>
+          </a:bodyPr>
+          <a:lstStyle/>
           <a:p>
             <a:pPr algn="l">
               <a:spcAft>
-                <a:spcPts val="500"/>
+                <a:spcPts val="400"/>
               </a:spcAft>
             </a:pPr>
             <a:r>
-              <a:rPr sz="1100" b="1" lang="en-GB">
+              <a:rPr sz="1200" b="1" lang="en-GB">
                 <a:solidFill>
                   <a:schemeClr val="tx2"/>
                 </a:solidFill>
               </a:rPr>
-              <a:t>Gelman, Hill &amp; Vehtari (2020). </a:t>
-            </a:r>
-            <a:r>
-              <a:rPr sz="1100" b="0" lang="en-GB">
+              <a:t>Country dummies: </a:t>
+            </a:r>
+            <a:r>
+              <a:rPr sz="1200" b="0" lang="en-GB">
                 <a:solidFill>
                   <a:schemeClr val="tx1"/>
                 </a:solidFill>
               </a:rPr>
-              <a:t>Regression and Other Stories, ch. 11 to 12 (free PDF).</a:t>
-            </a:r>
-          </a:p>
+              <a:t>+ C(country, Treatment("DE")) + C(season); per cent effects; two reasons</a:t>
+            </a:r>
+          </a:p>
+        </p:txBody>
+      </p:sp>
+      <p:sp>
+        <p:nvSpPr>
+          <p:cNvPr id="22" name="Fashion q row 4"/>
+          <p:cNvSpPr/>
+          <p:nvPr/>
+        </p:nvSpPr>
+        <p:spPr>
+          <a:xfrm>
+            <a:off x="457200" y="3392424"/>
+            <a:ext cx="8229600" cy="457200"/>
+          </a:xfrm>
+          <a:prstGeom prst="rect">
+            <a:avLst/>
+          </a:prstGeom>
+          <a:solidFill>
+            <a:schemeClr val="bg2"/>
+          </a:solidFill>
+          <a:ln>
+            <a:noFill/>
+          </a:ln>
+          <a:effectLst/>
+        </p:spPr>
+        <p:style>
+          <a:lnRef idx="1">
+            <a:schemeClr val="accent1"/>
+          </a:lnRef>
+          <a:fillRef idx="3">
+            <a:schemeClr val="accent1"/>
+          </a:fillRef>
+          <a:effectRef idx="2">
+            <a:schemeClr val="accent1"/>
+          </a:effectRef>
+          <a:fontRef idx="minor">
+            <a:schemeClr val="lt1"/>
+          </a:fontRef>
+        </p:style>
+        <p:txBody>
+          <a:bodyPr rtlCol="0" anchor="ctr"/>
+          <a:lstStyle/>
+          <a:p/>
+        </p:txBody>
+      </p:sp>
+      <p:sp>
+        <p:nvSpPr>
+          <p:cNvPr id="23" name="Fashion q number 4"/>
+          <p:cNvSpPr/>
+          <p:nvPr/>
+        </p:nvSpPr>
+        <p:spPr>
+          <a:xfrm>
+            <a:off x="594360" y="3465576"/>
+            <a:ext cx="310896" cy="310896"/>
+          </a:xfrm>
+          <a:prstGeom prst="ellipse">
+            <a:avLst/>
+          </a:prstGeom>
+          <a:solidFill>
+            <a:schemeClr val="tx2"/>
+          </a:solidFill>
+          <a:ln>
+            <a:noFill/>
+          </a:ln>
+          <a:effectLst/>
+        </p:spPr>
+        <p:style>
+          <a:lnRef idx="1">
+            <a:schemeClr val="accent1"/>
+          </a:lnRef>
+          <a:fillRef idx="3">
+            <a:schemeClr val="accent1"/>
+          </a:fillRef>
+          <a:effectRef idx="2">
+            <a:schemeClr val="accent1"/>
+          </a:effectRef>
+          <a:fontRef idx="minor">
+            <a:schemeClr val="lt1"/>
+          </a:fontRef>
+        </p:style>
+        <p:txBody>
+          <a:bodyPr rtlCol="0" anchor="ctr" lIns="0" rIns="0" tIns="0" bIns="0"/>
+          <a:lstStyle/>
+          <a:p>
+            <a:pPr algn="ctr"/>
+            <a:r>
+              <a:rPr sz="1200" b="1" lang="en-GB">
+                <a:solidFill>
+                  <a:schemeClr val="bg1"/>
+                </a:solidFill>
+              </a:rPr>
+              <a:t>4</a:t>
+            </a:r>
+          </a:p>
+        </p:txBody>
+      </p:sp>
+      <p:sp>
+        <p:nvSpPr>
+          <p:cNvPr id="24" name="Fashion q text 4"/>
+          <p:cNvSpPr txBox="1"/>
+          <p:nvPr/>
+        </p:nvSpPr>
+        <p:spPr>
+          <a:xfrm>
+            <a:off x="1051560" y="3392424"/>
+            <a:ext cx="7498080" cy="457200"/>
+          </a:xfrm>
+          <a:prstGeom prst="rect">
+            <a:avLst/>
+          </a:prstGeom>
+          <a:noFill/>
+        </p:spPr>
+        <p:txBody>
+          <a:bodyPr wrap="square" lIns="0" rIns="0" tIns="0" bIns="0" anchor="ctr">
+            <a:noAutofit/>
+          </a:bodyPr>
+          <a:lstStyle/>
           <a:p>
             <a:pPr algn="l">
               <a:spcAft>
-                <a:spcPts val="500"/>
+                <a:spcPts val="400"/>
               </a:spcAft>
             </a:pPr>
             <a:r>
-              <a:rPr sz="1100" b="1" lang="en-GB">
+              <a:rPr sz="1200" b="1" lang="en-GB">
                 <a:solidFill>
                   <a:schemeClr val="tx2"/>
                 </a:solidFill>
               </a:rPr>
-              <a:t>Turrell, A. </a:t>
-            </a:r>
-            <a:r>
-              <a:rPr sz="1100" b="0" lang="en-GB">
+              <a:t>Price, discount, sizes: </a:t>
+            </a:r>
+            <a:r>
+              <a:rPr sz="1200" b="0" lang="en-GB">
                 <a:solidFill>
                   <a:schemeClr val="tx1"/>
                 </a:solidFill>
               </a:rPr>
-              <a:t>Coding for Economists: regression diagnostics (free).</a:t>
-            </a:r>
-          </a:p>
+              <a:t>add them; is the price coefficient a price elasticity? Check with HC3</a:t>
+            </a:r>
+          </a:p>
+        </p:txBody>
+      </p:sp>
+      <p:sp>
+        <p:nvSpPr>
+          <p:cNvPr id="25" name="Fashion q row 5"/>
+          <p:cNvSpPr/>
+          <p:nvPr/>
+        </p:nvSpPr>
+        <p:spPr>
+          <a:xfrm>
+            <a:off x="457200" y="3913632"/>
+            <a:ext cx="8229600" cy="457200"/>
+          </a:xfrm>
+          <a:prstGeom prst="rect">
+            <a:avLst/>
+          </a:prstGeom>
+          <a:solidFill>
+            <a:schemeClr val="bg2"/>
+          </a:solidFill>
+          <a:ln>
+            <a:noFill/>
+          </a:ln>
+          <a:effectLst/>
+        </p:spPr>
+        <p:style>
+          <a:lnRef idx="1">
+            <a:schemeClr val="accent1"/>
+          </a:lnRef>
+          <a:fillRef idx="3">
+            <a:schemeClr val="accent1"/>
+          </a:fillRef>
+          <a:effectRef idx="2">
+            <a:schemeClr val="accent1"/>
+          </a:effectRef>
+          <a:fontRef idx="minor">
+            <a:schemeClr val="lt1"/>
+          </a:fontRef>
+        </p:style>
+        <p:txBody>
+          <a:bodyPr rtlCol="0" anchor="ctr"/>
+          <a:lstStyle/>
+          <a:p/>
+        </p:txBody>
+      </p:sp>
+      <p:sp>
+        <p:nvSpPr>
+          <p:cNvPr id="26" name="Fashion q number 5"/>
+          <p:cNvSpPr/>
+          <p:nvPr/>
+        </p:nvSpPr>
+        <p:spPr>
+          <a:xfrm>
+            <a:off x="594360" y="3986784"/>
+            <a:ext cx="310896" cy="310896"/>
+          </a:xfrm>
+          <a:prstGeom prst="ellipse">
+            <a:avLst/>
+          </a:prstGeom>
+          <a:solidFill>
+            <a:schemeClr val="tx2"/>
+          </a:solidFill>
+          <a:ln>
+            <a:noFill/>
+          </a:ln>
+          <a:effectLst/>
+        </p:spPr>
+        <p:style>
+          <a:lnRef idx="1">
+            <a:schemeClr val="accent1"/>
+          </a:lnRef>
+          <a:fillRef idx="3">
+            <a:schemeClr val="accent1"/>
+          </a:fillRef>
+          <a:effectRef idx="2">
+            <a:schemeClr val="accent1"/>
+          </a:effectRef>
+          <a:fontRef idx="minor">
+            <a:schemeClr val="lt1"/>
+          </a:fontRef>
+        </p:style>
+        <p:txBody>
+          <a:bodyPr rtlCol="0" anchor="ctr" lIns="0" rIns="0" tIns="0" bIns="0"/>
+          <a:lstStyle/>
+          <a:p>
+            <a:pPr algn="ctr"/>
+            <a:r>
+              <a:rPr sz="1200" b="1" lang="en-GB">
+                <a:solidFill>
+                  <a:schemeClr val="bg1"/>
+                </a:solidFill>
+              </a:rPr>
+              <a:t>5</a:t>
+            </a:r>
+          </a:p>
+        </p:txBody>
+      </p:sp>
+      <p:sp>
+        <p:nvSpPr>
+          <p:cNvPr id="27" name="Fashion q text 5"/>
+          <p:cNvSpPr txBox="1"/>
+          <p:nvPr/>
+        </p:nvSpPr>
+        <p:spPr>
+          <a:xfrm>
+            <a:off x="1051560" y="3913632"/>
+            <a:ext cx="7498080" cy="457200"/>
+          </a:xfrm>
+          <a:prstGeom prst="rect">
+            <a:avLst/>
+          </a:prstGeom>
+          <a:noFill/>
+        </p:spPr>
+        <p:txBody>
+          <a:bodyPr wrap="square" lIns="0" rIns="0" tIns="0" bIns="0" anchor="ctr">
+            <a:noAutofit/>
+          </a:bodyPr>
+          <a:lstStyle/>
           <a:p>
             <a:pPr algn="l">
               <a:spcAft>
-                <a:spcPts val="500"/>
+                <a:spcPts val="400"/>
               </a:spcAft>
             </a:pPr>
             <a:r>
-              <a:rPr sz="1100" b="1" lang="en-GB">
+              <a:rPr sz="1200" b="1" lang="en-GB">
                 <a:solidFill>
                   <a:schemeClr val="tx2"/>
                 </a:solidFill>
               </a:rPr>
-              <a:t>polars. </a:t>
-            </a:r>
-            <a:r>
-              <a:rPr sz="1100" b="0" lang="en-GB">
+              <a:t>Switzerland: </a:t>
+            </a:r>
+            <a:r>
+              <a:rPr sz="1200" b="0" lang="en-GB">
                 <a:solidFill>
                   <a:schemeClr val="tx1"/>
                 </a:solidFill>
               </a:rPr>
-              <a:t>when/then/otherwise and to_dummies (documentation).</a:t>
+              <a:t>CH vs DE and AT; why is nmv / (sold × price) higher? Invest or not?</a:t>
+            </a:r>
+          </a:p>
+        </p:txBody>
+      </p:sp>
+      <p:sp>
+        <p:nvSpPr>
+          <p:cNvPr id="28" name="Fashion file"/>
+          <p:cNvSpPr txBox="1"/>
+          <p:nvPr/>
+        </p:nvSpPr>
+        <p:spPr>
+          <a:xfrm>
+            <a:off x="457200" y="4572000"/>
+            <a:ext cx="8229600" cy="320040"/>
+          </a:xfrm>
+          <a:prstGeom prst="rect">
+            <a:avLst/>
+          </a:prstGeom>
+          <a:noFill/>
+        </p:spPr>
+        <p:txBody>
+          <a:bodyPr wrap="square" lIns="0" rIns="0" tIns="0" bIns="0" anchor="ctr">
+            <a:noAutofit/>
+          </a:bodyPr>
+          <a:lstStyle/>
+          <a:p>
+            <a:pPr algn="l">
+              <a:spcAft>
+                <a:spcPts val="400"/>
+              </a:spcAft>
+            </a:pPr>
+            <a:r>
+              <a:rPr sz="1200" b="1" lang="en-GB">
+                <a:solidFill>
+                  <a:schemeClr val="tx2"/>
+                </a:solidFill>
+              </a:rPr>
+              <a:t>File: </a:t>
+            </a:r>
+            <a:r>
+              <a:rPr sz="1200" b="0" lang="en-GB">
+                <a:solidFill>
+                  <a:schemeClr val="tx2"/>
+                </a:solidFill>
+                <a:latin typeface="Consolas"/>
+              </a:rPr>
+              <a:t>sessions/01-foundations/fashion_exercise.qmd</a:t>
+            </a:r>
+            <a:r>
+              <a:rPr sz="1200" b="0" lang="en-GB">
+                <a:solidFill>
+                  <a:schemeClr val="tx1"/>
+                </a:solidFill>
+              </a:rPr>
+              <a:t>  (data: data/fashion/fashion_countries.csv)</a:t>
             </a:r>
           </a:p>
         </p:txBody>
@@ -45252,7 +45612,1567 @@
 </p:sld>
 </file>
 
-<file path=ppt/slides/slide44.xml><?xml version="1.0" encoding="utf-8"?>
+<file path=ppt/slides/slide45.xml><?xml version="1.0" encoding="utf-8"?>
+<p:sld xmlns:a="http://schemas.openxmlformats.org/drawingml/2006/main" xmlns:p="http://schemas.openxmlformats.org/presentationml/2006/main" xmlns:r="http://schemas.openxmlformats.org/officeDocument/2006/relationships">
+  <p:cSld>
+    <p:spTree>
+      <p:nvGrpSpPr>
+        <p:cNvPr id="1" name=""/>
+        <p:cNvGrpSpPr/>
+        <p:nvPr/>
+      </p:nvGrpSpPr>
+      <p:grpSpPr/>
+      <p:sp>
+        <p:nvSpPr>
+          <p:cNvPr id="3" name="Title 2"/>
+          <p:cNvSpPr>
+            <a:spLocks noGrp="1"/>
+          </p:cNvSpPr>
+          <p:nvPr>
+            <p:ph type="title"/>
+          </p:nvPr>
+        </p:nvSpPr>
+        <p:spPr/>
+        <p:txBody>
+          <a:bodyPr/>
+          <a:lstStyle/>
+          <a:p>
+            <a:r>
+              <a:rPr sz="1600" lang="en-GB"/>
+              <a:t>Key takeaways</a:t>
+            </a:r>
+          </a:p>
+        </p:txBody>
+      </p:sp>
+      <p:sp>
+        <p:nvSpPr>
+          <p:cNvPr id="8" name="Fußzeilenplatzhalter 7"/>
+          <p:cNvSpPr>
+            <a:spLocks noGrp="1"/>
+          </p:cNvSpPr>
+          <p:nvPr>
+            <p:ph type="ftr" sz="quarter" idx="11"/>
+          </p:nvPr>
+        </p:nvSpPr>
+        <p:spPr/>
+        <p:txBody>
+          <a:bodyPr/>
+          <a:lstStyle/>
+          <a:p>
+            <a:r>
+              <a:rPr lang="en-GB"/>
+              <a:t>International Marketing Analytics · WT 2026/27</a:t>
+            </a:r>
+          </a:p>
+        </p:txBody>
+      </p:sp>
+      <p:sp>
+        <p:nvSpPr>
+          <p:cNvPr id="9" name="Foliennummernplatzhalter 8"/>
+          <p:cNvSpPr>
+            <a:spLocks noGrp="1"/>
+          </p:cNvSpPr>
+          <p:nvPr>
+            <p:ph type="sldNum" sz="quarter" idx="12"/>
+          </p:nvPr>
+        </p:nvSpPr>
+        <p:spPr/>
+        <p:txBody>
+          <a:bodyPr/>
+          <a:lstStyle/>
+          <a:p>
+            <a:r>
+              <a:rPr lang="en-GB" dirty="0"/>
+              <a:t>Page </a:t>
+            </a:r>
+            <a:fld id="{BE3DC40E-DBBE-4E2D-9EEC-FBF0DA0E9179}" type="slidenum">
+              <a:rPr lang="en-GB" smtClean="0"/>
+              <a:t>‹Nr.›</a:t>
+            </a:fld>
+            <a:endParaRPr lang="en-GB" dirty="0"/>
+          </a:p>
+        </p:txBody>
+      </p:sp>
+      <p:sp>
+        <p:nvSpPr>
+          <p:cNvPr id="10" name="Takeaways row 1"/>
+          <p:cNvSpPr/>
+          <p:nvPr/>
+        </p:nvSpPr>
+        <p:spPr>
+          <a:xfrm>
+            <a:off x="457200" y="1234440"/>
+            <a:ext cx="8229600" cy="585216"/>
+          </a:xfrm>
+          <a:prstGeom prst="rect">
+            <a:avLst/>
+          </a:prstGeom>
+          <a:solidFill>
+            <a:schemeClr val="bg2"/>
+          </a:solidFill>
+          <a:ln>
+            <a:noFill/>
+          </a:ln>
+          <a:effectLst/>
+        </p:spPr>
+        <p:style>
+          <a:lnRef idx="1">
+            <a:schemeClr val="accent1"/>
+          </a:lnRef>
+          <a:fillRef idx="3">
+            <a:schemeClr val="accent1"/>
+          </a:fillRef>
+          <a:effectRef idx="2">
+            <a:schemeClr val="accent1"/>
+          </a:effectRef>
+          <a:fontRef idx="minor">
+            <a:schemeClr val="lt1"/>
+          </a:fontRef>
+        </p:style>
+        <p:txBody>
+          <a:bodyPr rtlCol="0" anchor="ctr"/>
+          <a:lstStyle/>
+          <a:p/>
+        </p:txBody>
+      </p:sp>
+      <p:sp>
+        <p:nvSpPr>
+          <p:cNvPr id="11" name="Takeaways number 1"/>
+          <p:cNvSpPr/>
+          <p:nvPr/>
+        </p:nvSpPr>
+        <p:spPr>
+          <a:xfrm>
+            <a:off x="594360" y="1371600"/>
+            <a:ext cx="310896" cy="310896"/>
+          </a:xfrm>
+          <a:prstGeom prst="ellipse">
+            <a:avLst/>
+          </a:prstGeom>
+          <a:solidFill>
+            <a:schemeClr val="tx2"/>
+          </a:solidFill>
+          <a:ln>
+            <a:noFill/>
+          </a:ln>
+          <a:effectLst/>
+        </p:spPr>
+        <p:style>
+          <a:lnRef idx="1">
+            <a:schemeClr val="accent1"/>
+          </a:lnRef>
+          <a:fillRef idx="3">
+            <a:schemeClr val="accent1"/>
+          </a:fillRef>
+          <a:effectRef idx="2">
+            <a:schemeClr val="accent1"/>
+          </a:effectRef>
+          <a:fontRef idx="minor">
+            <a:schemeClr val="lt1"/>
+          </a:fontRef>
+        </p:style>
+        <p:txBody>
+          <a:bodyPr rtlCol="0" anchor="ctr" lIns="0" rIns="0" tIns="0" bIns="0"/>
+          <a:lstStyle/>
+          <a:p>
+            <a:pPr algn="ctr"/>
+            <a:r>
+              <a:rPr sz="1200" b="1" lang="en-GB">
+                <a:solidFill>
+                  <a:schemeClr val="bg1"/>
+                </a:solidFill>
+              </a:rPr>
+              <a:t>1</a:t>
+            </a:r>
+          </a:p>
+        </p:txBody>
+      </p:sp>
+      <p:sp>
+        <p:nvSpPr>
+          <p:cNvPr id="12" name="Takeaways text 1"/>
+          <p:cNvSpPr txBox="1"/>
+          <p:nvPr/>
+        </p:nvSpPr>
+        <p:spPr>
+          <a:xfrm>
+            <a:off x="1051560" y="1234440"/>
+            <a:ext cx="7498080" cy="585216"/>
+          </a:xfrm>
+          <a:prstGeom prst="rect">
+            <a:avLst/>
+          </a:prstGeom>
+          <a:noFill/>
+        </p:spPr>
+        <p:txBody>
+          <a:bodyPr wrap="square" lIns="0" rIns="0" tIns="0" bIns="0" anchor="ctr">
+            <a:noAutofit/>
+          </a:bodyPr>
+          <a:lstStyle/>
+          <a:p>
+            <a:pPr algn="l">
+              <a:spcAft>
+                <a:spcPts val="400"/>
+              </a:spcAft>
+            </a:pPr>
+            <a:r>
+              <a:rPr sz="1200" b="1" lang="en-GB">
+                <a:solidFill>
+                  <a:schemeClr val="tx2"/>
+                </a:solidFill>
+              </a:rPr>
+              <a:t>Look, then test, then fix: </a:t>
+            </a:r>
+            <a:r>
+              <a:rPr sz="1200" b="0" lang="en-GB">
+                <a:solidFill>
+                  <a:schemeClr val="tx1"/>
+                </a:solidFill>
+              </a:rPr>
+              <a:t>residual and Q-Q plots; RESET, Breusch-Pagan, Jarque-Bera, VIF, Cook's distance</a:t>
+            </a:r>
+          </a:p>
+        </p:txBody>
+      </p:sp>
+      <p:sp>
+        <p:nvSpPr>
+          <p:cNvPr id="13" name="Takeaways row 2"/>
+          <p:cNvSpPr/>
+          <p:nvPr/>
+        </p:nvSpPr>
+        <p:spPr>
+          <a:xfrm>
+            <a:off x="457200" y="1901952"/>
+            <a:ext cx="8229600" cy="585216"/>
+          </a:xfrm>
+          <a:prstGeom prst="rect">
+            <a:avLst/>
+          </a:prstGeom>
+          <a:solidFill>
+            <a:schemeClr val="bg2"/>
+          </a:solidFill>
+          <a:ln>
+            <a:noFill/>
+          </a:ln>
+          <a:effectLst/>
+        </p:spPr>
+        <p:style>
+          <a:lnRef idx="1">
+            <a:schemeClr val="accent1"/>
+          </a:lnRef>
+          <a:fillRef idx="3">
+            <a:schemeClr val="accent1"/>
+          </a:fillRef>
+          <a:effectRef idx="2">
+            <a:schemeClr val="accent1"/>
+          </a:effectRef>
+          <a:fontRef idx="minor">
+            <a:schemeClr val="lt1"/>
+          </a:fontRef>
+        </p:style>
+        <p:txBody>
+          <a:bodyPr rtlCol="0" anchor="ctr"/>
+          <a:lstStyle/>
+          <a:p/>
+        </p:txBody>
+      </p:sp>
+      <p:sp>
+        <p:nvSpPr>
+          <p:cNvPr id="14" name="Takeaways number 2"/>
+          <p:cNvSpPr/>
+          <p:nvPr/>
+        </p:nvSpPr>
+        <p:spPr>
+          <a:xfrm>
+            <a:off x="594360" y="2039112"/>
+            <a:ext cx="310896" cy="310896"/>
+          </a:xfrm>
+          <a:prstGeom prst="ellipse">
+            <a:avLst/>
+          </a:prstGeom>
+          <a:solidFill>
+            <a:schemeClr val="tx2"/>
+          </a:solidFill>
+          <a:ln>
+            <a:noFill/>
+          </a:ln>
+          <a:effectLst/>
+        </p:spPr>
+        <p:style>
+          <a:lnRef idx="1">
+            <a:schemeClr val="accent1"/>
+          </a:lnRef>
+          <a:fillRef idx="3">
+            <a:schemeClr val="accent1"/>
+          </a:fillRef>
+          <a:effectRef idx="2">
+            <a:schemeClr val="accent1"/>
+          </a:effectRef>
+          <a:fontRef idx="minor">
+            <a:schemeClr val="lt1"/>
+          </a:fontRef>
+        </p:style>
+        <p:txBody>
+          <a:bodyPr rtlCol="0" anchor="ctr" lIns="0" rIns="0" tIns="0" bIns="0"/>
+          <a:lstStyle/>
+          <a:p>
+            <a:pPr algn="ctr"/>
+            <a:r>
+              <a:rPr sz="1200" b="1" lang="en-GB">
+                <a:solidFill>
+                  <a:schemeClr val="bg1"/>
+                </a:solidFill>
+              </a:rPr>
+              <a:t>2</a:t>
+            </a:r>
+          </a:p>
+        </p:txBody>
+      </p:sp>
+      <p:sp>
+        <p:nvSpPr>
+          <p:cNvPr id="15" name="Takeaways text 2"/>
+          <p:cNvSpPr txBox="1"/>
+          <p:nvPr/>
+        </p:nvSpPr>
+        <p:spPr>
+          <a:xfrm>
+            <a:off x="1051560" y="1901952"/>
+            <a:ext cx="7498080" cy="585216"/>
+          </a:xfrm>
+          <a:prstGeom prst="rect">
+            <a:avLst/>
+          </a:prstGeom>
+          <a:noFill/>
+        </p:spPr>
+        <p:txBody>
+          <a:bodyPr wrap="square" lIns="0" rIns="0" tIns="0" bIns="0" anchor="ctr">
+            <a:noAutofit/>
+          </a:bodyPr>
+          <a:lstStyle/>
+          <a:p>
+            <a:pPr algn="l">
+              <a:spcAft>
+                <a:spcPts val="400"/>
+              </a:spcAft>
+            </a:pPr>
+            <a:r>
+              <a:rPr sz="1200" b="1" lang="en-GB">
+                <a:solidFill>
+                  <a:schemeClr val="tx2"/>
+                </a:solidFill>
+              </a:rPr>
+              <a:t>In assumption tests </a:t>
+            </a:r>
+            <a:r>
+              <a:rPr sz="1200" b="0" lang="en-GB">
+                <a:solidFill>
+                  <a:schemeClr val="tx1"/>
+                </a:solidFill>
+              </a:rPr>
+              <a:t>a small p is bad news</a:t>
+            </a:r>
+          </a:p>
+        </p:txBody>
+      </p:sp>
+      <p:sp>
+        <p:nvSpPr>
+          <p:cNvPr id="16" name="Takeaways row 3"/>
+          <p:cNvSpPr/>
+          <p:nvPr/>
+        </p:nvSpPr>
+        <p:spPr>
+          <a:xfrm>
+            <a:off x="457200" y="2569464"/>
+            <a:ext cx="8229600" cy="585216"/>
+          </a:xfrm>
+          <a:prstGeom prst="rect">
+            <a:avLst/>
+          </a:prstGeom>
+          <a:solidFill>
+            <a:schemeClr val="bg2"/>
+          </a:solidFill>
+          <a:ln>
+            <a:noFill/>
+          </a:ln>
+          <a:effectLst/>
+        </p:spPr>
+        <p:style>
+          <a:lnRef idx="1">
+            <a:schemeClr val="accent1"/>
+          </a:lnRef>
+          <a:fillRef idx="3">
+            <a:schemeClr val="accent1"/>
+          </a:fillRef>
+          <a:effectRef idx="2">
+            <a:schemeClr val="accent1"/>
+          </a:effectRef>
+          <a:fontRef idx="minor">
+            <a:schemeClr val="lt1"/>
+          </a:fontRef>
+        </p:style>
+        <p:txBody>
+          <a:bodyPr rtlCol="0" anchor="ctr"/>
+          <a:lstStyle/>
+          <a:p/>
+        </p:txBody>
+      </p:sp>
+      <p:sp>
+        <p:nvSpPr>
+          <p:cNvPr id="17" name="Takeaways number 3"/>
+          <p:cNvSpPr/>
+          <p:nvPr/>
+        </p:nvSpPr>
+        <p:spPr>
+          <a:xfrm>
+            <a:off x="594360" y="2706624"/>
+            <a:ext cx="310896" cy="310896"/>
+          </a:xfrm>
+          <a:prstGeom prst="ellipse">
+            <a:avLst/>
+          </a:prstGeom>
+          <a:solidFill>
+            <a:schemeClr val="tx2"/>
+          </a:solidFill>
+          <a:ln>
+            <a:noFill/>
+          </a:ln>
+          <a:effectLst/>
+        </p:spPr>
+        <p:style>
+          <a:lnRef idx="1">
+            <a:schemeClr val="accent1"/>
+          </a:lnRef>
+          <a:fillRef idx="3">
+            <a:schemeClr val="accent1"/>
+          </a:fillRef>
+          <a:effectRef idx="2">
+            <a:schemeClr val="accent1"/>
+          </a:effectRef>
+          <a:fontRef idx="minor">
+            <a:schemeClr val="lt1"/>
+          </a:fontRef>
+        </p:style>
+        <p:txBody>
+          <a:bodyPr rtlCol="0" anchor="ctr" lIns="0" rIns="0" tIns="0" bIns="0"/>
+          <a:lstStyle/>
+          <a:p>
+            <a:pPr algn="ctr"/>
+            <a:r>
+              <a:rPr sz="1200" b="1" lang="en-GB">
+                <a:solidFill>
+                  <a:schemeClr val="bg1"/>
+                </a:solidFill>
+              </a:rPr>
+              <a:t>3</a:t>
+            </a:r>
+          </a:p>
+        </p:txBody>
+      </p:sp>
+      <p:sp>
+        <p:nvSpPr>
+          <p:cNvPr id="18" name="Takeaways text 3"/>
+          <p:cNvSpPr txBox="1"/>
+          <p:nvPr/>
+        </p:nvSpPr>
+        <p:spPr>
+          <a:xfrm>
+            <a:off x="1051560" y="2569464"/>
+            <a:ext cx="7498080" cy="585216"/>
+          </a:xfrm>
+          <a:prstGeom prst="rect">
+            <a:avLst/>
+          </a:prstGeom>
+          <a:noFill/>
+        </p:spPr>
+        <p:txBody>
+          <a:bodyPr wrap="square" lIns="0" rIns="0" tIns="0" bIns="0" anchor="ctr">
+            <a:noAutofit/>
+          </a:bodyPr>
+          <a:lstStyle/>
+          <a:p>
+            <a:pPr algn="l">
+              <a:spcAft>
+                <a:spcPts val="400"/>
+              </a:spcAft>
+            </a:pPr>
+            <a:r>
+              <a:rPr sz="1200" b="1" lang="en-GB">
+                <a:solidFill>
+                  <a:schemeClr val="tx2"/>
+                </a:solidFill>
+              </a:rPr>
+              <a:t>Dummies: </a:t>
+            </a:r>
+            <a:r>
+              <a:rPr sz="1200" b="0" lang="en-GB">
+                <a:solidFill>
+                  <a:schemeClr val="tx1"/>
+                </a:solidFill>
+              </a:rPr>
+              <a:t>k − 1 for k groups; each b is a difference to the reference; count the 1s</a:t>
+            </a:r>
+          </a:p>
+        </p:txBody>
+      </p:sp>
+      <p:sp>
+        <p:nvSpPr>
+          <p:cNvPr id="19" name="Takeaways row 4"/>
+          <p:cNvSpPr/>
+          <p:nvPr/>
+        </p:nvSpPr>
+        <p:spPr>
+          <a:xfrm>
+            <a:off x="457200" y="3236976"/>
+            <a:ext cx="8229600" cy="585216"/>
+          </a:xfrm>
+          <a:prstGeom prst="rect">
+            <a:avLst/>
+          </a:prstGeom>
+          <a:solidFill>
+            <a:schemeClr val="bg2"/>
+          </a:solidFill>
+          <a:ln>
+            <a:noFill/>
+          </a:ln>
+          <a:effectLst/>
+        </p:spPr>
+        <p:style>
+          <a:lnRef idx="1">
+            <a:schemeClr val="accent1"/>
+          </a:lnRef>
+          <a:fillRef idx="3">
+            <a:schemeClr val="accent1"/>
+          </a:fillRef>
+          <a:effectRef idx="2">
+            <a:schemeClr val="accent1"/>
+          </a:effectRef>
+          <a:fontRef idx="minor">
+            <a:schemeClr val="lt1"/>
+          </a:fontRef>
+        </p:style>
+        <p:txBody>
+          <a:bodyPr rtlCol="0" anchor="ctr"/>
+          <a:lstStyle/>
+          <a:p/>
+        </p:txBody>
+      </p:sp>
+      <p:sp>
+        <p:nvSpPr>
+          <p:cNvPr id="20" name="Takeaways number 4"/>
+          <p:cNvSpPr/>
+          <p:nvPr/>
+        </p:nvSpPr>
+        <p:spPr>
+          <a:xfrm>
+            <a:off x="594360" y="3374136"/>
+            <a:ext cx="310896" cy="310896"/>
+          </a:xfrm>
+          <a:prstGeom prst="ellipse">
+            <a:avLst/>
+          </a:prstGeom>
+          <a:solidFill>
+            <a:schemeClr val="tx2"/>
+          </a:solidFill>
+          <a:ln>
+            <a:noFill/>
+          </a:ln>
+          <a:effectLst/>
+        </p:spPr>
+        <p:style>
+          <a:lnRef idx="1">
+            <a:schemeClr val="accent1"/>
+          </a:lnRef>
+          <a:fillRef idx="3">
+            <a:schemeClr val="accent1"/>
+          </a:fillRef>
+          <a:effectRef idx="2">
+            <a:schemeClr val="accent1"/>
+          </a:effectRef>
+          <a:fontRef idx="minor">
+            <a:schemeClr val="lt1"/>
+          </a:fontRef>
+        </p:style>
+        <p:txBody>
+          <a:bodyPr rtlCol="0" anchor="ctr" lIns="0" rIns="0" tIns="0" bIns="0"/>
+          <a:lstStyle/>
+          <a:p>
+            <a:pPr algn="ctr"/>
+            <a:r>
+              <a:rPr sz="1200" b="1" lang="en-GB">
+                <a:solidFill>
+                  <a:schemeClr val="bg1"/>
+                </a:solidFill>
+              </a:rPr>
+              <a:t>4</a:t>
+            </a:r>
+          </a:p>
+        </p:txBody>
+      </p:sp>
+      <p:sp>
+        <p:nvSpPr>
+          <p:cNvPr id="21" name="Takeaways text 4"/>
+          <p:cNvSpPr txBox="1"/>
+          <p:nvPr/>
+        </p:nvSpPr>
+        <p:spPr>
+          <a:xfrm>
+            <a:off x="1051560" y="3236976"/>
+            <a:ext cx="7498080" cy="585216"/>
+          </a:xfrm>
+          <a:prstGeom prst="rect">
+            <a:avLst/>
+          </a:prstGeom>
+          <a:noFill/>
+        </p:spPr>
+        <p:txBody>
+          <a:bodyPr wrap="square" lIns="0" rIns="0" tIns="0" bIns="0" anchor="ctr">
+            <a:noAutofit/>
+          </a:bodyPr>
+          <a:lstStyle/>
+          <a:p>
+            <a:pPr algn="l">
+              <a:spcAft>
+                <a:spcPts val="400"/>
+              </a:spcAft>
+            </a:pPr>
+            <a:r>
+              <a:rPr sz="1200" b="1" lang="en-GB">
+                <a:solidFill>
+                  <a:schemeClr val="tx2"/>
+                </a:solidFill>
+              </a:rPr>
+              <a:t>Logs: </a:t>
+            </a:r>
+            <a:r>
+              <a:rPr sz="1200" b="0" lang="en-GB">
+                <a:solidFill>
+                  <a:schemeClr val="tx1"/>
+                </a:solidFill>
+              </a:rPr>
+              <a:t>elasticities, per cent effects, better residuals; compare models by tests, not R²</a:t>
+            </a:r>
+          </a:p>
+        </p:txBody>
+      </p:sp>
+      <p:sp>
+        <p:nvSpPr>
+          <p:cNvPr id="22" name="Takeaways row 5"/>
+          <p:cNvSpPr/>
+          <p:nvPr/>
+        </p:nvSpPr>
+        <p:spPr>
+          <a:xfrm>
+            <a:off x="457200" y="3904488"/>
+            <a:ext cx="8229600" cy="585216"/>
+          </a:xfrm>
+          <a:prstGeom prst="rect">
+            <a:avLst/>
+          </a:prstGeom>
+          <a:solidFill>
+            <a:schemeClr val="bg2"/>
+          </a:solidFill>
+          <a:ln>
+            <a:noFill/>
+          </a:ln>
+          <a:effectLst/>
+        </p:spPr>
+        <p:style>
+          <a:lnRef idx="1">
+            <a:schemeClr val="accent1"/>
+          </a:lnRef>
+          <a:fillRef idx="3">
+            <a:schemeClr val="accent1"/>
+          </a:fillRef>
+          <a:effectRef idx="2">
+            <a:schemeClr val="accent1"/>
+          </a:effectRef>
+          <a:fontRef idx="minor">
+            <a:schemeClr val="lt1"/>
+          </a:fontRef>
+        </p:style>
+        <p:txBody>
+          <a:bodyPr rtlCol="0" anchor="ctr"/>
+          <a:lstStyle/>
+          <a:p/>
+        </p:txBody>
+      </p:sp>
+      <p:sp>
+        <p:nvSpPr>
+          <p:cNvPr id="23" name="Takeaways number 5"/>
+          <p:cNvSpPr/>
+          <p:nvPr/>
+        </p:nvSpPr>
+        <p:spPr>
+          <a:xfrm>
+            <a:off x="594360" y="4041648"/>
+            <a:ext cx="310896" cy="310896"/>
+          </a:xfrm>
+          <a:prstGeom prst="ellipse">
+            <a:avLst/>
+          </a:prstGeom>
+          <a:solidFill>
+            <a:schemeClr val="tx2"/>
+          </a:solidFill>
+          <a:ln>
+            <a:noFill/>
+          </a:ln>
+          <a:effectLst/>
+        </p:spPr>
+        <p:style>
+          <a:lnRef idx="1">
+            <a:schemeClr val="accent1"/>
+          </a:lnRef>
+          <a:fillRef idx="3">
+            <a:schemeClr val="accent1"/>
+          </a:fillRef>
+          <a:effectRef idx="2">
+            <a:schemeClr val="accent1"/>
+          </a:effectRef>
+          <a:fontRef idx="minor">
+            <a:schemeClr val="lt1"/>
+          </a:fontRef>
+        </p:style>
+        <p:txBody>
+          <a:bodyPr rtlCol="0" anchor="ctr" lIns="0" rIns="0" tIns="0" bIns="0"/>
+          <a:lstStyle/>
+          <a:p>
+            <a:pPr algn="ctr"/>
+            <a:r>
+              <a:rPr sz="1200" b="1" lang="en-GB">
+                <a:solidFill>
+                  <a:schemeClr val="bg1"/>
+                </a:solidFill>
+              </a:rPr>
+              <a:t>5</a:t>
+            </a:r>
+          </a:p>
+        </p:txBody>
+      </p:sp>
+      <p:sp>
+        <p:nvSpPr>
+          <p:cNvPr id="24" name="Takeaways text 5"/>
+          <p:cNvSpPr txBox="1"/>
+          <p:nvPr/>
+        </p:nvSpPr>
+        <p:spPr>
+          <a:xfrm>
+            <a:off x="1051560" y="3904488"/>
+            <a:ext cx="7498080" cy="585216"/>
+          </a:xfrm>
+          <a:prstGeom prst="rect">
+            <a:avLst/>
+          </a:prstGeom>
+          <a:noFill/>
+        </p:spPr>
+        <p:txBody>
+          <a:bodyPr wrap="square" lIns="0" rIns="0" tIns="0" bIns="0" anchor="ctr">
+            <a:noAutofit/>
+          </a:bodyPr>
+          <a:lstStyle/>
+          <a:p>
+            <a:pPr algn="l">
+              <a:spcAft>
+                <a:spcPts val="400"/>
+              </a:spcAft>
+            </a:pPr>
+            <a:r>
+              <a:rPr sz="1200" b="1" lang="en-GB">
+                <a:solidFill>
+                  <a:schemeClr val="tx2"/>
+                </a:solidFill>
+              </a:rPr>
+              <a:t>Curves: </a:t>
+            </a:r>
+            <a:r>
+              <a:rPr sz="1200" b="0" lang="en-GB">
+                <a:solidFill>
+                  <a:schemeClr val="tx1"/>
+                </a:solidFill>
+              </a:rPr>
+              <a:t>squares and logs keep OLS linear in b; never read a curve beyond the data</a:t>
+            </a:r>
+          </a:p>
+        </p:txBody>
+      </p:sp>
+      <p:sp>
+        <p:nvSpPr>
+          <p:cNvPr id="25" name="Takeaway next box"/>
+          <p:cNvSpPr/>
+          <p:nvPr/>
+        </p:nvSpPr>
+        <p:spPr>
+          <a:xfrm>
+            <a:off x="457200" y="4572000"/>
+            <a:ext cx="8229600" cy="457200"/>
+          </a:xfrm>
+          <a:prstGeom prst="rect">
+            <a:avLst/>
+          </a:prstGeom>
+          <a:solidFill>
+            <a:schemeClr val="tx2"/>
+          </a:solidFill>
+          <a:ln>
+            <a:noFill/>
+          </a:ln>
+          <a:effectLst/>
+        </p:spPr>
+        <p:style>
+          <a:lnRef idx="1">
+            <a:schemeClr val="accent1"/>
+          </a:lnRef>
+          <a:fillRef idx="3">
+            <a:schemeClr val="accent1"/>
+          </a:fillRef>
+          <a:effectRef idx="2">
+            <a:schemeClr val="accent1"/>
+          </a:effectRef>
+          <a:fontRef idx="minor">
+            <a:schemeClr val="lt1"/>
+          </a:fontRef>
+        </p:style>
+        <p:txBody>
+          <a:bodyPr rtlCol="0" anchor="ctr"/>
+          <a:lstStyle/>
+          <a:p/>
+        </p:txBody>
+      </p:sp>
+      <p:pic>
+        <p:nvPicPr>
+          <p:cNvPr id="26" name="Icon Takeaway next" descr=""/>
+          <p:cNvPicPr>
+            <a:picLocks noChangeAspect="1"/>
+          </p:cNvPicPr>
+          <p:nvPr/>
+        </p:nvPicPr>
+        <p:blipFill>
+          <a:blip r:embed="rId3"/>
+          <a:stretch>
+            <a:fillRect/>
+          </a:stretch>
+        </p:blipFill>
+        <p:spPr>
+          <a:xfrm>
+            <a:off x="658368" y="4617720"/>
+            <a:ext cx="365760" cy="365760"/>
+          </a:xfrm>
+          <a:prstGeom prst="rect">
+            <a:avLst/>
+          </a:prstGeom>
+        </p:spPr>
+      </p:pic>
+      <p:sp>
+        <p:nvSpPr>
+          <p:cNvPr id="27" name="Takeaway next text"/>
+          <p:cNvSpPr txBox="1"/>
+          <p:nvPr/>
+        </p:nvSpPr>
+        <p:spPr>
+          <a:xfrm>
+            <a:off x="1207008" y="4572000"/>
+            <a:ext cx="7315200" cy="457200"/>
+          </a:xfrm>
+          <a:prstGeom prst="rect">
+            <a:avLst/>
+          </a:prstGeom>
+          <a:noFill/>
+        </p:spPr>
+        <p:txBody>
+          <a:bodyPr wrap="square" lIns="0" rIns="0" tIns="0" bIns="0" anchor="ctr">
+            <a:noAutofit/>
+          </a:bodyPr>
+          <a:lstStyle/>
+          <a:p>
+            <a:pPr algn="l">
+              <a:spcAft>
+                <a:spcPts val="400"/>
+              </a:spcAft>
+            </a:pPr>
+            <a:r>
+              <a:rPr sz="1200" b="1" lang="en-GB">
+                <a:solidFill>
+                  <a:schemeClr val="bg1"/>
+                </a:solidFill>
+              </a:rPr>
+              <a:t>Homework: </a:t>
+            </a:r>
+            <a:r>
+              <a:rPr sz="1200" b="0" lang="en-GB">
+                <a:solidFill>
+                  <a:schemeClr val="bg1"/>
+                </a:solidFill>
+              </a:rPr>
+              <a:t>coding exercise 2 with your personal data, brief on Canvas.</a:t>
+            </a:r>
+          </a:p>
+        </p:txBody>
+      </p:sp>
+    </p:spTree>
+  </p:cSld>
+  <p:clrMapOvr>
+    <a:masterClrMapping/>
+  </p:clrMapOvr>
+</p:sld>
+</file>
+
+<file path=ppt/slides/slide46.xml><?xml version="1.0" encoding="utf-8"?>
+<p:sld xmlns:a="http://schemas.openxmlformats.org/drawingml/2006/main" xmlns:p="http://schemas.openxmlformats.org/presentationml/2006/main" xmlns:r="http://schemas.openxmlformats.org/officeDocument/2006/relationships">
+  <p:cSld>
+    <p:spTree>
+      <p:nvGrpSpPr>
+        <p:cNvPr id="1" name=""/>
+        <p:cNvGrpSpPr/>
+        <p:nvPr/>
+      </p:nvGrpSpPr>
+      <p:grpSpPr/>
+      <p:sp>
+        <p:nvSpPr>
+          <p:cNvPr id="3" name="Title 2"/>
+          <p:cNvSpPr>
+            <a:spLocks noGrp="1"/>
+          </p:cNvSpPr>
+          <p:nvPr>
+            <p:ph type="title"/>
+          </p:nvPr>
+        </p:nvSpPr>
+        <p:spPr/>
+        <p:txBody>
+          <a:bodyPr/>
+          <a:lstStyle/>
+          <a:p>
+            <a:r>
+              <a:rPr sz="1600" lang="en-GB"/>
+              <a:t>References</a:t>
+            </a:r>
+          </a:p>
+        </p:txBody>
+      </p:sp>
+      <p:sp>
+        <p:nvSpPr>
+          <p:cNvPr id="8" name="Fußzeilenplatzhalter 7"/>
+          <p:cNvSpPr>
+            <a:spLocks noGrp="1"/>
+          </p:cNvSpPr>
+          <p:nvPr>
+            <p:ph type="ftr" sz="quarter" idx="11"/>
+          </p:nvPr>
+        </p:nvSpPr>
+        <p:spPr/>
+        <p:txBody>
+          <a:bodyPr/>
+          <a:lstStyle/>
+          <a:p>
+            <a:r>
+              <a:rPr lang="en-GB"/>
+              <a:t>International Marketing Analytics · WT 2026/27</a:t>
+            </a:r>
+          </a:p>
+        </p:txBody>
+      </p:sp>
+      <p:sp>
+        <p:nvSpPr>
+          <p:cNvPr id="9" name="Foliennummernplatzhalter 8"/>
+          <p:cNvSpPr>
+            <a:spLocks noGrp="1"/>
+          </p:cNvSpPr>
+          <p:nvPr>
+            <p:ph type="sldNum" sz="quarter" idx="12"/>
+          </p:nvPr>
+        </p:nvSpPr>
+        <p:spPr/>
+        <p:txBody>
+          <a:bodyPr/>
+          <a:lstStyle/>
+          <a:p>
+            <a:r>
+              <a:rPr lang="en-GB" dirty="0"/>
+              <a:t>Page </a:t>
+            </a:r>
+            <a:fld id="{BE3DC40E-DBBE-4E2D-9EEC-FBF0DA0E9179}" type="slidenum">
+              <a:rPr lang="en-GB" smtClean="0"/>
+              <a:t>‹Nr.›</a:t>
+            </a:fld>
+            <a:endParaRPr lang="en-GB" dirty="0"/>
+          </a:p>
+        </p:txBody>
+      </p:sp>
+      <p:sp>
+        <p:nvSpPr>
+          <p:cNvPr id="10" name="Ref 1 header"/>
+          <p:cNvSpPr/>
+          <p:nvPr/>
+        </p:nvSpPr>
+        <p:spPr>
+          <a:xfrm>
+            <a:off x="457200" y="1234440"/>
+            <a:ext cx="4046220" cy="411480"/>
+          </a:xfrm>
+          <a:prstGeom prst="rect">
+            <a:avLst/>
+          </a:prstGeom>
+          <a:solidFill>
+            <a:schemeClr val="accent1"/>
+          </a:solidFill>
+          <a:ln>
+            <a:noFill/>
+          </a:ln>
+          <a:effectLst/>
+        </p:spPr>
+        <p:style>
+          <a:lnRef idx="1">
+            <a:schemeClr val="accent1"/>
+          </a:lnRef>
+          <a:fillRef idx="3">
+            <a:schemeClr val="accent1"/>
+          </a:fillRef>
+          <a:effectRef idx="2">
+            <a:schemeClr val="accent1"/>
+          </a:effectRef>
+          <a:fontRef idx="minor">
+            <a:schemeClr val="lt1"/>
+          </a:fontRef>
+        </p:style>
+        <p:txBody>
+          <a:bodyPr rtlCol="0" anchor="ctr"/>
+          <a:lstStyle/>
+          <a:p/>
+        </p:txBody>
+      </p:sp>
+      <p:sp>
+        <p:nvSpPr>
+          <p:cNvPr id="11" name="Ref 1 heading"/>
+          <p:cNvSpPr txBox="1"/>
+          <p:nvPr/>
+        </p:nvSpPr>
+        <p:spPr>
+          <a:xfrm>
+            <a:off x="594360" y="1234440"/>
+            <a:ext cx="3360420" cy="411480"/>
+          </a:xfrm>
+          <a:prstGeom prst="rect">
+            <a:avLst/>
+          </a:prstGeom>
+          <a:noFill/>
+        </p:spPr>
+        <p:txBody>
+          <a:bodyPr wrap="square" lIns="0" rIns="0" tIns="0" bIns="0" anchor="ctr">
+            <a:noAutofit/>
+          </a:bodyPr>
+          <a:lstStyle/>
+          <a:p>
+            <a:pPr algn="l">
+              <a:spcAft>
+                <a:spcPts val="400"/>
+              </a:spcAft>
+            </a:pPr>
+            <a:r>
+              <a:rPr sz="1500" b="1" lang="en-GB">
+                <a:solidFill>
+                  <a:schemeClr val="bg1"/>
+                </a:solidFill>
+                <a:latin typeface="+mj-lt"/>
+              </a:rPr>
+              <a:t>Academic</a:t>
+            </a:r>
+          </a:p>
+        </p:txBody>
+      </p:sp>
+      <p:pic>
+        <p:nvPicPr>
+          <p:cNvPr id="12" name="Icon ref 1" descr=""/>
+          <p:cNvPicPr>
+            <a:picLocks noChangeAspect="1"/>
+          </p:cNvPicPr>
+          <p:nvPr/>
+        </p:nvPicPr>
+        <p:blipFill>
+          <a:blip r:embed="rId3"/>
+          <a:stretch>
+            <a:fillRect/>
+          </a:stretch>
+        </p:blipFill>
+        <p:spPr>
+          <a:xfrm>
+            <a:off x="4064508" y="1280160"/>
+            <a:ext cx="310896" cy="310896"/>
+          </a:xfrm>
+          <a:prstGeom prst="rect">
+            <a:avLst/>
+          </a:prstGeom>
+        </p:spPr>
+      </p:pic>
+      <p:sp>
+        <p:nvSpPr>
+          <p:cNvPr id="13" name="Ref 1 body"/>
+          <p:cNvSpPr/>
+          <p:nvPr/>
+        </p:nvSpPr>
+        <p:spPr>
+          <a:xfrm>
+            <a:off x="457200" y="1645920"/>
+            <a:ext cx="4046220" cy="3429000"/>
+          </a:xfrm>
+          <a:prstGeom prst="rect">
+            <a:avLst/>
+          </a:prstGeom>
+          <a:solidFill>
+            <a:schemeClr val="bg2"/>
+          </a:solidFill>
+          <a:ln>
+            <a:noFill/>
+          </a:ln>
+          <a:effectLst/>
+        </p:spPr>
+        <p:style>
+          <a:lnRef idx="1">
+            <a:schemeClr val="accent1"/>
+          </a:lnRef>
+          <a:fillRef idx="3">
+            <a:schemeClr val="accent1"/>
+          </a:fillRef>
+          <a:effectRef idx="2">
+            <a:schemeClr val="accent1"/>
+          </a:effectRef>
+          <a:fontRef idx="minor">
+            <a:schemeClr val="lt1"/>
+          </a:fontRef>
+        </p:style>
+        <p:txBody>
+          <a:bodyPr rtlCol="0" anchor="ctr"/>
+          <a:lstStyle/>
+          <a:p/>
+        </p:txBody>
+      </p:sp>
+      <p:sp>
+        <p:nvSpPr>
+          <p:cNvPr id="14" name="Ref 1 text"/>
+          <p:cNvSpPr txBox="1"/>
+          <p:nvPr/>
+        </p:nvSpPr>
+        <p:spPr>
+          <a:xfrm>
+            <a:off x="621792" y="1737360"/>
+            <a:ext cx="3744468" cy="3291840"/>
+          </a:xfrm>
+          <a:prstGeom prst="rect">
+            <a:avLst/>
+          </a:prstGeom>
+          <a:noFill/>
+        </p:spPr>
+        <p:txBody>
+          <a:bodyPr wrap="square" lIns="0" rIns="0" tIns="0" bIns="0" anchor="t">
+            <a:noAutofit/>
+          </a:bodyPr>
+          <a:lstStyle/>
+          <a:p>
+            <a:pPr algn="l">
+              <a:spcAft>
+                <a:spcPts val="500"/>
+              </a:spcAft>
+            </a:pPr>
+            <a:r>
+              <a:rPr sz="1100" b="1" lang="en-GB">
+                <a:solidFill>
+                  <a:schemeClr val="tx2"/>
+                </a:solidFill>
+              </a:rPr>
+              <a:t>Skiera, B., Reiner, J. &amp; Albers, S. (2022). </a:t>
+            </a:r>
+            <a:r>
+              <a:rPr sz="1100" b="0" lang="en-GB">
+                <a:solidFill>
+                  <a:schemeClr val="tx1"/>
+                </a:solidFill>
+              </a:rPr>
+              <a:t>Regression analysis. In Homburg et al. (eds), Handbook of Market Research, 299–327. Springer.</a:t>
+            </a:r>
+          </a:p>
+          <a:p>
+            <a:pPr algn="l">
+              <a:spcAft>
+                <a:spcPts val="500"/>
+              </a:spcAft>
+            </a:pPr>
+            <a:r>
+              <a:rPr sz="1100" b="1" lang="en-GB">
+                <a:solidFill>
+                  <a:schemeClr val="tx2"/>
+                </a:solidFill>
+              </a:rPr>
+              <a:t>Bojinov, I. I., Parzen, M. &amp; Hamilton, P. J. (2025). </a:t>
+            </a:r>
+            <a:r>
+              <a:rPr sz="1100" b="0" lang="en-GB">
+                <a:solidFill>
+                  <a:schemeClr val="tx1"/>
+                </a:solidFill>
+              </a:rPr>
+              <a:t>Linear Regression. HBS note 9-622-100 (Canvas).</a:t>
+            </a:r>
+          </a:p>
+          <a:p>
+            <a:pPr algn="l">
+              <a:spcAft>
+                <a:spcPts val="500"/>
+              </a:spcAft>
+            </a:pPr>
+            <a:r>
+              <a:rPr sz="1100" b="1" lang="en-GB">
+                <a:solidFill>
+                  <a:schemeClr val="tx2"/>
+                </a:solidFill>
+              </a:rPr>
+              <a:t>Wooldridge, J. M. (2025). </a:t>
+            </a:r>
+            <a:r>
+              <a:rPr sz="1100" b="0" lang="en-GB">
+                <a:solidFill>
+                  <a:schemeClr val="tx1"/>
+                </a:solidFill>
+              </a:rPr>
+              <a:t>Introductory Econometrics, 8th ed. Cengage. Ch. 6 to 9.</a:t>
+            </a:r>
+          </a:p>
+          <a:p>
+            <a:pPr algn="l">
+              <a:spcAft>
+                <a:spcPts val="500"/>
+              </a:spcAft>
+            </a:pPr>
+            <a:r>
+              <a:rPr sz="1100" b="1" lang="en-GB">
+                <a:solidFill>
+                  <a:schemeClr val="tx2"/>
+                </a:solidFill>
+              </a:rPr>
+              <a:t>Hanssens, D. M., Parsons, L. J. &amp; Schultz, R. L. (2001). </a:t>
+            </a:r>
+            <a:r>
+              <a:rPr sz="1100" b="0" lang="en-GB">
+                <a:solidFill>
+                  <a:schemeClr val="tx1"/>
+                </a:solidFill>
+              </a:rPr>
+              <a:t>Market Response Models. Kluwer.</a:t>
+            </a:r>
+          </a:p>
+          <a:p>
+            <a:pPr algn="l">
+              <a:spcAft>
+                <a:spcPts val="500"/>
+              </a:spcAft>
+            </a:pPr>
+            <a:r>
+              <a:rPr sz="1100" b="1" lang="en-GB">
+                <a:solidFill>
+                  <a:schemeClr val="tx2"/>
+                </a:solidFill>
+              </a:rPr>
+              <a:t>Hair, J. F. et al. (2019). </a:t>
+            </a:r>
+            <a:r>
+              <a:rPr sz="1100" b="0" lang="en-GB">
+                <a:solidFill>
+                  <a:schemeClr val="tx1"/>
+                </a:solidFill>
+              </a:rPr>
+              <a:t>Multivariate Data Analysis, 8th ed. Cengage. Ch. 5.</a:t>
+            </a:r>
+          </a:p>
+        </p:txBody>
+      </p:sp>
+      <p:sp>
+        <p:nvSpPr>
+          <p:cNvPr id="15" name="Ref 2 header"/>
+          <p:cNvSpPr/>
+          <p:nvPr/>
+        </p:nvSpPr>
+        <p:spPr>
+          <a:xfrm>
+            <a:off x="4640580" y="1234440"/>
+            <a:ext cx="4046220" cy="411480"/>
+          </a:xfrm>
+          <a:prstGeom prst="rect">
+            <a:avLst/>
+          </a:prstGeom>
+          <a:solidFill>
+            <a:schemeClr val="accent1"/>
+          </a:solidFill>
+          <a:ln>
+            <a:noFill/>
+          </a:ln>
+          <a:effectLst/>
+        </p:spPr>
+        <p:style>
+          <a:lnRef idx="1">
+            <a:schemeClr val="accent1"/>
+          </a:lnRef>
+          <a:fillRef idx="3">
+            <a:schemeClr val="accent1"/>
+          </a:fillRef>
+          <a:effectRef idx="2">
+            <a:schemeClr val="accent1"/>
+          </a:effectRef>
+          <a:fontRef idx="minor">
+            <a:schemeClr val="lt1"/>
+          </a:fontRef>
+        </p:style>
+        <p:txBody>
+          <a:bodyPr rtlCol="0" anchor="ctr"/>
+          <a:lstStyle/>
+          <a:p/>
+        </p:txBody>
+      </p:sp>
+      <p:sp>
+        <p:nvSpPr>
+          <p:cNvPr id="16" name="Ref 2 heading"/>
+          <p:cNvSpPr txBox="1"/>
+          <p:nvPr/>
+        </p:nvSpPr>
+        <p:spPr>
+          <a:xfrm>
+            <a:off x="4777740" y="1234440"/>
+            <a:ext cx="3360420" cy="411480"/>
+          </a:xfrm>
+          <a:prstGeom prst="rect">
+            <a:avLst/>
+          </a:prstGeom>
+          <a:noFill/>
+        </p:spPr>
+        <p:txBody>
+          <a:bodyPr wrap="square" lIns="0" rIns="0" tIns="0" bIns="0" anchor="ctr">
+            <a:noAutofit/>
+          </a:bodyPr>
+          <a:lstStyle/>
+          <a:p>
+            <a:pPr algn="l">
+              <a:spcAft>
+                <a:spcPts val="400"/>
+              </a:spcAft>
+            </a:pPr>
+            <a:r>
+              <a:rPr sz="1500" b="1" lang="en-GB">
+                <a:solidFill>
+                  <a:schemeClr val="bg1"/>
+                </a:solidFill>
+                <a:latin typeface="+mj-lt"/>
+              </a:rPr>
+              <a:t>Learning resources</a:t>
+            </a:r>
+          </a:p>
+        </p:txBody>
+      </p:sp>
+      <p:pic>
+        <p:nvPicPr>
+          <p:cNvPr id="17" name="Icon ref 2" descr=""/>
+          <p:cNvPicPr>
+            <a:picLocks noChangeAspect="1"/>
+          </p:cNvPicPr>
+          <p:nvPr/>
+        </p:nvPicPr>
+        <p:blipFill>
+          <a:blip r:embed="rId4"/>
+          <a:stretch>
+            <a:fillRect/>
+          </a:stretch>
+        </p:blipFill>
+        <p:spPr>
+          <a:xfrm>
+            <a:off x="8247888" y="1280160"/>
+            <a:ext cx="310896" cy="310896"/>
+          </a:xfrm>
+          <a:prstGeom prst="rect">
+            <a:avLst/>
+          </a:prstGeom>
+        </p:spPr>
+      </p:pic>
+      <p:sp>
+        <p:nvSpPr>
+          <p:cNvPr id="18" name="Ref 2 body"/>
+          <p:cNvSpPr/>
+          <p:nvPr/>
+        </p:nvSpPr>
+        <p:spPr>
+          <a:xfrm>
+            <a:off x="4640580" y="1645920"/>
+            <a:ext cx="4046220" cy="3429000"/>
+          </a:xfrm>
+          <a:prstGeom prst="rect">
+            <a:avLst/>
+          </a:prstGeom>
+          <a:solidFill>
+            <a:schemeClr val="bg2"/>
+          </a:solidFill>
+          <a:ln>
+            <a:noFill/>
+          </a:ln>
+          <a:effectLst/>
+        </p:spPr>
+        <p:style>
+          <a:lnRef idx="1">
+            <a:schemeClr val="accent1"/>
+          </a:lnRef>
+          <a:fillRef idx="3">
+            <a:schemeClr val="accent1"/>
+          </a:fillRef>
+          <a:effectRef idx="2">
+            <a:schemeClr val="accent1"/>
+          </a:effectRef>
+          <a:fontRef idx="minor">
+            <a:schemeClr val="lt1"/>
+          </a:fontRef>
+        </p:style>
+        <p:txBody>
+          <a:bodyPr rtlCol="0" anchor="ctr"/>
+          <a:lstStyle/>
+          <a:p/>
+        </p:txBody>
+      </p:sp>
+      <p:sp>
+        <p:nvSpPr>
+          <p:cNvPr id="19" name="Ref 2 text"/>
+          <p:cNvSpPr txBox="1"/>
+          <p:nvPr/>
+        </p:nvSpPr>
+        <p:spPr>
+          <a:xfrm>
+            <a:off x="4805172" y="1737360"/>
+            <a:ext cx="3744468" cy="3291840"/>
+          </a:xfrm>
+          <a:prstGeom prst="rect">
+            <a:avLst/>
+          </a:prstGeom>
+          <a:noFill/>
+        </p:spPr>
+        <p:txBody>
+          <a:bodyPr wrap="square" lIns="0" rIns="0" tIns="0" bIns="0" anchor="t">
+            <a:noAutofit/>
+          </a:bodyPr>
+          <a:lstStyle/>
+          <a:p>
+            <a:pPr algn="l">
+              <a:spcAft>
+                <a:spcPts val="500"/>
+              </a:spcAft>
+            </a:pPr>
+            <a:r>
+              <a:rPr sz="1100" b="1" lang="en-GB">
+                <a:solidFill>
+                  <a:schemeClr val="tx2"/>
+                </a:solidFill>
+              </a:rPr>
+              <a:t>James, G. et al. (2023). </a:t>
+            </a:r>
+            <a:r>
+              <a:rPr sz="1100" b="0" lang="en-GB">
+                <a:solidFill>
+                  <a:schemeClr val="tx1"/>
+                </a:solidFill>
+              </a:rPr>
+              <a:t>ISLP, ch. 3.3 and the Python lab (free).</a:t>
+            </a:r>
+          </a:p>
+          <a:p>
+            <a:pPr algn="l">
+              <a:spcAft>
+                <a:spcPts val="500"/>
+              </a:spcAft>
+            </a:pPr>
+            <a:r>
+              <a:rPr sz="1100" b="1" lang="en-GB">
+                <a:solidFill>
+                  <a:schemeClr val="tx2"/>
+                </a:solidFill>
+              </a:rPr>
+              <a:t>statsmodels. </a:t>
+            </a:r>
+            <a:r>
+              <a:rPr sz="1100" b="0" lang="en-GB">
+                <a:solidFill>
+                  <a:schemeClr val="tx1"/>
+                </a:solidFill>
+              </a:rPr>
+              <a:t>Regression diagnostics and specification tests (documentation).</a:t>
+            </a:r>
+          </a:p>
+          <a:p>
+            <a:pPr algn="l">
+              <a:spcAft>
+                <a:spcPts val="500"/>
+              </a:spcAft>
+            </a:pPr>
+            <a:r>
+              <a:rPr sz="1100" b="1" lang="en-GB">
+                <a:solidFill>
+                  <a:schemeClr val="tx2"/>
+                </a:solidFill>
+              </a:rPr>
+              <a:t>Gelman, Hill &amp; Vehtari (2020). </a:t>
+            </a:r>
+            <a:r>
+              <a:rPr sz="1100" b="0" lang="en-GB">
+                <a:solidFill>
+                  <a:schemeClr val="tx1"/>
+                </a:solidFill>
+              </a:rPr>
+              <a:t>Regression and Other Stories, ch. 11 to 12 (free PDF).</a:t>
+            </a:r>
+          </a:p>
+          <a:p>
+            <a:pPr algn="l">
+              <a:spcAft>
+                <a:spcPts val="500"/>
+              </a:spcAft>
+            </a:pPr>
+            <a:r>
+              <a:rPr sz="1100" b="1" lang="en-GB">
+                <a:solidFill>
+                  <a:schemeClr val="tx2"/>
+                </a:solidFill>
+              </a:rPr>
+              <a:t>Turrell, A. </a:t>
+            </a:r>
+            <a:r>
+              <a:rPr sz="1100" b="0" lang="en-GB">
+                <a:solidFill>
+                  <a:schemeClr val="tx1"/>
+                </a:solidFill>
+              </a:rPr>
+              <a:t>Coding for Economists: regression diagnostics (free).</a:t>
+            </a:r>
+          </a:p>
+          <a:p>
+            <a:pPr algn="l">
+              <a:spcAft>
+                <a:spcPts val="500"/>
+              </a:spcAft>
+            </a:pPr>
+            <a:r>
+              <a:rPr sz="1100" b="1" lang="en-GB">
+                <a:solidFill>
+                  <a:schemeClr val="tx2"/>
+                </a:solidFill>
+              </a:rPr>
+              <a:t>polars. </a:t>
+            </a:r>
+            <a:r>
+              <a:rPr sz="1100" b="0" lang="en-GB">
+                <a:solidFill>
+                  <a:schemeClr val="tx1"/>
+                </a:solidFill>
+              </a:rPr>
+              <a:t>when/then/otherwise and to_dummies (documentation).</a:t>
+            </a:r>
+          </a:p>
+        </p:txBody>
+      </p:sp>
+    </p:spTree>
+  </p:cSld>
+  <p:clrMapOvr>
+    <a:masterClrMapping/>
+  </p:clrMapOvr>
+</p:sld>
+</file>
+
+<file path=ppt/slides/slide47.xml><?xml version="1.0" encoding="utf-8"?>
 <p:sld xmlns:a="http://schemas.openxmlformats.org/drawingml/2006/main" xmlns:p="http://schemas.openxmlformats.org/presentationml/2006/main" xmlns:r="http://schemas.openxmlformats.org/officeDocument/2006/relationships">
   <p:cSld>
     <p:spTree>

</xml_diff>